<commit_message>
fix: create pytest temp parent for clean checkouts
</commit_message>
<xml_diff>
--- a/presentation/slides.pptx
+++ b/presentation/slides.pptx
@@ -2,28 +2,28 @@
 <file path=ppt/presentation.xml><?xml version="1.0" encoding="utf-8"?>
 <p:presentation xmlns:p="http://schemas.openxmlformats.org/presentationml/2006/main">
   <p:sldMasterIdLst>
-    <p:sldMasterId xmlns:r="http://schemas.openxmlformats.org/officeDocument/2006/relationships" id="2147483648" r:id="R80992ca82c6f461a"/>
+    <p:sldMasterId xmlns:r="http://schemas.openxmlformats.org/officeDocument/2006/relationships" id="2147483648" r:id="Ra96055ae58eb4813"/>
   </p:sldMasterIdLst>
   <p:notesMasterIdLst>
-    <p:notesMasterId xmlns:r="http://schemas.openxmlformats.org/officeDocument/2006/relationships" r:id="Rebdd19cb51924c4f"/>
+    <p:notesMasterId xmlns:r="http://schemas.openxmlformats.org/officeDocument/2006/relationships" r:id="R87f29b3c856f4437"/>
   </p:notesMasterIdLst>
   <p:sldIdLst>
-    <p:sldId xmlns:r="http://schemas.openxmlformats.org/officeDocument/2006/relationships" id="256" r:id="R92fb10cb61134020"/>
-    <p:sldId xmlns:r="http://schemas.openxmlformats.org/officeDocument/2006/relationships" id="257" r:id="R5c1d8d5efc7b49be"/>
-    <p:sldId xmlns:r="http://schemas.openxmlformats.org/officeDocument/2006/relationships" id="258" r:id="R58d84d66e5f94ec1"/>
-    <p:sldId xmlns:r="http://schemas.openxmlformats.org/officeDocument/2006/relationships" id="259" r:id="R70c35503157c4698"/>
-    <p:sldId xmlns:r="http://schemas.openxmlformats.org/officeDocument/2006/relationships" id="260" r:id="R71c68ee4fac14ffe"/>
-    <p:sldId xmlns:r="http://schemas.openxmlformats.org/officeDocument/2006/relationships" id="261" r:id="Ra7153f80747c428f"/>
-    <p:sldId xmlns:r="http://schemas.openxmlformats.org/officeDocument/2006/relationships" id="262" r:id="R70364d1c44014ecf"/>
-    <p:sldId xmlns:r="http://schemas.openxmlformats.org/officeDocument/2006/relationships" id="263" r:id="Recc4281032fd4521"/>
-    <p:sldId xmlns:r="http://schemas.openxmlformats.org/officeDocument/2006/relationships" id="264" r:id="R0513c0832e4b4d61"/>
-    <p:sldId xmlns:r="http://schemas.openxmlformats.org/officeDocument/2006/relationships" id="265" r:id="R6721a333ba6b4e8f"/>
-    <p:sldId xmlns:r="http://schemas.openxmlformats.org/officeDocument/2006/relationships" id="266" r:id="R601935c88efe4913"/>
-    <p:sldId xmlns:r="http://schemas.openxmlformats.org/officeDocument/2006/relationships" id="267" r:id="R41993b1417ec4291"/>
-    <p:sldId xmlns:r="http://schemas.openxmlformats.org/officeDocument/2006/relationships" id="268" r:id="R4c451ca6d8ac4ab4"/>
-    <p:sldId xmlns:r="http://schemas.openxmlformats.org/officeDocument/2006/relationships" id="269" r:id="R009c80ae824d4b05"/>
-    <p:sldId xmlns:r="http://schemas.openxmlformats.org/officeDocument/2006/relationships" id="270" r:id="Rff1e2496af7d4b12"/>
-    <p:sldId xmlns:r="http://schemas.openxmlformats.org/officeDocument/2006/relationships" id="271" r:id="R27d20adcf6fb4da9"/>
+    <p:sldId xmlns:r="http://schemas.openxmlformats.org/officeDocument/2006/relationships" id="256" r:id="R7e2ed537c3994917"/>
+    <p:sldId xmlns:r="http://schemas.openxmlformats.org/officeDocument/2006/relationships" id="257" r:id="R725b46a2cbcb4d03"/>
+    <p:sldId xmlns:r="http://schemas.openxmlformats.org/officeDocument/2006/relationships" id="258" r:id="R93512a3f9a264b94"/>
+    <p:sldId xmlns:r="http://schemas.openxmlformats.org/officeDocument/2006/relationships" id="259" r:id="Rc5d8abb7a7bd4a86"/>
+    <p:sldId xmlns:r="http://schemas.openxmlformats.org/officeDocument/2006/relationships" id="260" r:id="R8ca8362ff6474e80"/>
+    <p:sldId xmlns:r="http://schemas.openxmlformats.org/officeDocument/2006/relationships" id="261" r:id="Rfd87a31ebde14530"/>
+    <p:sldId xmlns:r="http://schemas.openxmlformats.org/officeDocument/2006/relationships" id="262" r:id="R8e7fccfdabf549ef"/>
+    <p:sldId xmlns:r="http://schemas.openxmlformats.org/officeDocument/2006/relationships" id="263" r:id="Rfd4dc838a29e4a24"/>
+    <p:sldId xmlns:r="http://schemas.openxmlformats.org/officeDocument/2006/relationships" id="264" r:id="R9bd08e19267344fb"/>
+    <p:sldId xmlns:r="http://schemas.openxmlformats.org/officeDocument/2006/relationships" id="265" r:id="R94dea03c656b4d00"/>
+    <p:sldId xmlns:r="http://schemas.openxmlformats.org/officeDocument/2006/relationships" id="266" r:id="Raaf0a9fa45a9404f"/>
+    <p:sldId xmlns:r="http://schemas.openxmlformats.org/officeDocument/2006/relationships" id="267" r:id="R9bf4fab9f05f40f4"/>
+    <p:sldId xmlns:r="http://schemas.openxmlformats.org/officeDocument/2006/relationships" id="268" r:id="Rc4d15712f37c430e"/>
+    <p:sldId xmlns:r="http://schemas.openxmlformats.org/officeDocument/2006/relationships" id="269" r:id="R54d839aa665346d2"/>
+    <p:sldId xmlns:r="http://schemas.openxmlformats.org/officeDocument/2006/relationships" id="270" r:id="R46bce58565844738"/>
+    <p:sldId xmlns:r="http://schemas.openxmlformats.org/officeDocument/2006/relationships" id="271" r:id="R6a828441fce24b29"/>
   </p:sldIdLst>
   <p:sldSz cx="12192000" cy="6858000"/>
   <p:notesSz cx="6858000" cy="9144000"/>
@@ -1714,7 +1714,7 @@
           <p:cNvPr id="3" name="Title">
             <a:extLst xmlns:a="http://schemas.openxmlformats.org/drawingml/2006/main">
               <a:ext uri="{FF2B5EF4-FFF2-40B4-BE49-F238E27FC236}">
-                <a16:creationId xmlns:a16="http://schemas.microsoft.com/office/drawing/2014/main" id="{FC27B588-BAC6-4A65-A776-592EBEE2D258}"/>
+                <a16:creationId xmlns:a16="http://schemas.microsoft.com/office/drawing/2014/main" id="{BF9CA437-88D6-4AE3-947F-24073D948955}"/>
               </a:ext>
             </a:extLst>
           </p:cNvPr>
@@ -1871,7 +1871,7 @@
           <p:cNvPr id="2" name="Subtitle">
             <a:extLst xmlns:a="http://schemas.openxmlformats.org/drawingml/2006/main">
               <a:ext uri="{FF2B5EF4-FFF2-40B4-BE49-F238E27FC236}">
-                <a16:creationId xmlns:a16="http://schemas.microsoft.com/office/drawing/2014/main" id="{687E2548-9B64-4F63-B68A-EFC022E1371B}"/>
+                <a16:creationId xmlns:a16="http://schemas.microsoft.com/office/drawing/2014/main" id="{656BA4CF-ED76-4027-AE6E-09413CA4789D}"/>
               </a:ext>
             </a:extLst>
           </p:cNvPr>
@@ -2045,7 +2045,7 @@
           <p:cNvPr id="2" name="Section title">
             <a:extLst xmlns:a="http://schemas.openxmlformats.org/drawingml/2006/main">
               <a:ext uri="{FF2B5EF4-FFF2-40B4-BE49-F238E27FC236}">
-                <a16:creationId xmlns:a16="http://schemas.microsoft.com/office/drawing/2014/main" id="{BC0BD789-C945-4739-8C1B-447AD9982B68}"/>
+                <a16:creationId xmlns:a16="http://schemas.microsoft.com/office/drawing/2014/main" id="{9D921CB8-81AB-4367-A842-F02F627ED832}"/>
               </a:ext>
             </a:extLst>
           </p:cNvPr>
@@ -2219,7 +2219,7 @@
           <p:cNvPr id="3" name="Title">
             <a:extLst xmlns:a="http://schemas.openxmlformats.org/drawingml/2006/main">
               <a:ext uri="{FF2B5EF4-FFF2-40B4-BE49-F238E27FC236}">
-                <a16:creationId xmlns:a16="http://schemas.microsoft.com/office/drawing/2014/main" id="{C647A6FF-824E-4532-BEC0-CDC1E7C750F3}"/>
+                <a16:creationId xmlns:a16="http://schemas.microsoft.com/office/drawing/2014/main" id="{D8CF2DAC-ED30-41DB-89ED-ED5ED4AC7D04}"/>
               </a:ext>
             </a:extLst>
           </p:cNvPr>
@@ -2376,7 +2376,7 @@
           <p:cNvPr id="2" name="Body">
             <a:extLst xmlns:a="http://schemas.openxmlformats.org/drawingml/2006/main">
               <a:ext uri="{FF2B5EF4-FFF2-40B4-BE49-F238E27FC236}">
-                <a16:creationId xmlns:a16="http://schemas.microsoft.com/office/drawing/2014/main" id="{4EE45545-0316-4C69-9B73-AA628C602A6B}"/>
+                <a16:creationId xmlns:a16="http://schemas.microsoft.com/office/drawing/2014/main" id="{58D6BDBE-1544-400A-95F7-666BF23B7AD7}"/>
               </a:ext>
             </a:extLst>
           </p:cNvPr>
@@ -2550,7 +2550,7 @@
           <p:cNvPr id="4" name="Title">
             <a:extLst xmlns:a="http://schemas.openxmlformats.org/drawingml/2006/main">
               <a:ext uri="{FF2B5EF4-FFF2-40B4-BE49-F238E27FC236}">
-                <a16:creationId xmlns:a16="http://schemas.microsoft.com/office/drawing/2014/main" id="{02B02E2A-0EE0-45A1-91AB-64F3D336822F}"/>
+                <a16:creationId xmlns:a16="http://schemas.microsoft.com/office/drawing/2014/main" id="{201904D5-077F-48B0-92A8-A74ED32A0ACE}"/>
               </a:ext>
             </a:extLst>
           </p:cNvPr>
@@ -2707,7 +2707,7 @@
           <p:cNvPr id="2" name="Left column">
             <a:extLst xmlns:a="http://schemas.openxmlformats.org/drawingml/2006/main">
               <a:ext uri="{FF2B5EF4-FFF2-40B4-BE49-F238E27FC236}">
-                <a16:creationId xmlns:a16="http://schemas.microsoft.com/office/drawing/2014/main" id="{FF053F4E-C2E2-4055-97AB-83C19B58E91B}"/>
+                <a16:creationId xmlns:a16="http://schemas.microsoft.com/office/drawing/2014/main" id="{CE8B5743-5317-48B4-A3B4-C2F753DF585E}"/>
               </a:ext>
             </a:extLst>
           </p:cNvPr>
@@ -2864,7 +2864,7 @@
           <p:cNvPr id="3" name="Right column">
             <a:extLst xmlns:a="http://schemas.openxmlformats.org/drawingml/2006/main">
               <a:ext uri="{FF2B5EF4-FFF2-40B4-BE49-F238E27FC236}">
-                <a16:creationId xmlns:a16="http://schemas.microsoft.com/office/drawing/2014/main" id="{BF1691CE-6490-460A-B177-CA943A700D60}"/>
+                <a16:creationId xmlns:a16="http://schemas.microsoft.com/office/drawing/2014/main" id="{3D2B2230-E260-4937-A1CC-560E3CEE67BA}"/>
               </a:ext>
             </a:extLst>
           </p:cNvPr>
@@ -3038,7 +3038,7 @@
           <p:cNvPr id="3" name="Title">
             <a:extLst xmlns:a="http://schemas.openxmlformats.org/drawingml/2006/main">
               <a:ext uri="{FF2B5EF4-FFF2-40B4-BE49-F238E27FC236}">
-                <a16:creationId xmlns:a16="http://schemas.microsoft.com/office/drawing/2014/main" id="{39424D47-7C85-4242-9328-1B3D2BB8E7EC}"/>
+                <a16:creationId xmlns:a16="http://schemas.microsoft.com/office/drawing/2014/main" id="{E70BB465-7B1F-4606-9064-A06BB61469C2}"/>
               </a:ext>
             </a:extLst>
           </p:cNvPr>
@@ -3195,7 +3195,7 @@
           <p:cNvPr id="2" name="Left column">
             <a:extLst xmlns:a="http://schemas.openxmlformats.org/drawingml/2006/main">
               <a:ext uri="{FF2B5EF4-FFF2-40B4-BE49-F238E27FC236}">
-                <a16:creationId xmlns:a16="http://schemas.microsoft.com/office/drawing/2014/main" id="{C1AA4928-B0FE-451B-8880-99CDE583CA96}"/>
+                <a16:creationId xmlns:a16="http://schemas.microsoft.com/office/drawing/2014/main" id="{DD37D628-0DD3-4E12-89D7-F5D62F9B59C3}"/>
               </a:ext>
             </a:extLst>
           </p:cNvPr>
@@ -3390,12 +3390,12 @@
   </p:cSld>
   <p:clrMap bg1="lt1" tx1="dk1" bg2="lt2" tx2="dk2" accent1="accent1" accent2="accent2" accent3="accent3" accent4="accent4" accent5="accent5" accent6="accent6" hlink="hlink" folHlink="folHlink"/>
   <p:sldLayoutIdLst>
-    <p:sldLayoutId xmlns:r="http://schemas.openxmlformats.org/officeDocument/2006/relationships" id="2147483649" r:id="R1e0d5cfa38eb47c7"/>
-    <p:sldLayoutId xmlns:r="http://schemas.openxmlformats.org/officeDocument/2006/relationships" id="2147483650" r:id="R998ed9fc408d47b8"/>
-    <p:sldLayoutId xmlns:r="http://schemas.openxmlformats.org/officeDocument/2006/relationships" id="2147483651" r:id="Re8f81cb222f1473a"/>
-    <p:sldLayoutId xmlns:r="http://schemas.openxmlformats.org/officeDocument/2006/relationships" id="2147483652" r:id="R85165c1a6bad4a70"/>
-    <p:sldLayoutId xmlns:r="http://schemas.openxmlformats.org/officeDocument/2006/relationships" id="2147483653" r:id="Rb06e226d145d4632"/>
-    <p:sldLayoutId xmlns:r="http://schemas.openxmlformats.org/officeDocument/2006/relationships" id="2147483654" r:id="R12bc379aa7a446d3"/>
+    <p:sldLayoutId xmlns:r="http://schemas.openxmlformats.org/officeDocument/2006/relationships" id="2147483649" r:id="Ref7b6f3f223a4692"/>
+    <p:sldLayoutId xmlns:r="http://schemas.openxmlformats.org/officeDocument/2006/relationships" id="2147483650" r:id="R3166b186f3c44f9b"/>
+    <p:sldLayoutId xmlns:r="http://schemas.openxmlformats.org/officeDocument/2006/relationships" id="2147483651" r:id="R75569c3ad22c4493"/>
+    <p:sldLayoutId xmlns:r="http://schemas.openxmlformats.org/officeDocument/2006/relationships" id="2147483652" r:id="R67843351c0e04beb"/>
+    <p:sldLayoutId xmlns:r="http://schemas.openxmlformats.org/officeDocument/2006/relationships" id="2147483653" r:id="R174bc646638c4826"/>
+    <p:sldLayoutId xmlns:r="http://schemas.openxmlformats.org/officeDocument/2006/relationships" id="2147483654" r:id="Rac9c41478cdc449d"/>
   </p:sldLayoutIdLst>
   <p:txStyles>
     <p:titleStyle>
@@ -4634,7 +4634,7 @@
           <p:cNvPr id="6" name="">
             <a:extLst xmlns:a="http://schemas.openxmlformats.org/drawingml/2006/main">
               <a:ext uri="{FF2B5EF4-FFF2-40B4-BE49-F238E27FC236}">
-                <a16:creationId xmlns:a16="http://schemas.microsoft.com/office/drawing/2014/main" id="{71AD0F10-294C-4F6F-AF57-0F51EA9716D0}"/>
+                <a16:creationId xmlns:a16="http://schemas.microsoft.com/office/drawing/2014/main" id="{31B206A2-2346-4479-A10F-6D6901575AB8}"/>
               </a:ext>
             </a:extLst>
           </p:cNvPr>
@@ -4664,7 +4664,7 @@
           <p:cNvPr id="2" name="">
             <a:extLst xmlns:a="http://schemas.openxmlformats.org/drawingml/2006/main">
               <a:ext uri="{FF2B5EF4-FFF2-40B4-BE49-F238E27FC236}">
-                <a16:creationId xmlns:a16="http://schemas.microsoft.com/office/drawing/2014/main" id="{94DA6F44-0D31-4DB2-9252-F91DBCE93A16}"/>
+                <a16:creationId xmlns:a16="http://schemas.microsoft.com/office/drawing/2014/main" id="{47CDE5FF-D8CD-4046-8C60-9B8661450750}"/>
               </a:ext>
             </a:extLst>
           </p:cNvPr>
@@ -4732,7 +4732,7 @@
           <p:cNvPr id="3" name="">
             <a:extLst xmlns:a="http://schemas.openxmlformats.org/drawingml/2006/main">
               <a:ext uri="{FF2B5EF4-FFF2-40B4-BE49-F238E27FC236}">
-                <a16:creationId xmlns:a16="http://schemas.microsoft.com/office/drawing/2014/main" id="{FBA26728-DAFA-49EB-86E1-2E8056EE96DD}"/>
+                <a16:creationId xmlns:a16="http://schemas.microsoft.com/office/drawing/2014/main" id="{C29BA8FB-66CB-4BEE-8DA9-0928DD72115E}"/>
               </a:ext>
             </a:extLst>
           </p:cNvPr>
@@ -4800,7 +4800,7 @@
           <p:cNvPr id="4" name="">
             <a:extLst xmlns:a="http://schemas.openxmlformats.org/drawingml/2006/main">
               <a:ext uri="{FF2B5EF4-FFF2-40B4-BE49-F238E27FC236}">
-                <a16:creationId xmlns:a16="http://schemas.microsoft.com/office/drawing/2014/main" id="{F89918C4-2420-4AB5-B98E-BF4289065E33}"/>
+                <a16:creationId xmlns:a16="http://schemas.microsoft.com/office/drawing/2014/main" id="{93C3FA3B-3B51-4D11-887B-A0696298BD21}"/>
               </a:ext>
             </a:extLst>
           </p:cNvPr>
@@ -4868,7 +4868,7 @@
           <p:cNvPr id="5" name="">
             <a:extLst xmlns:a="http://schemas.openxmlformats.org/drawingml/2006/main">
               <a:ext uri="{FF2B5EF4-FFF2-40B4-BE49-F238E27FC236}">
-                <a16:creationId xmlns:a16="http://schemas.microsoft.com/office/drawing/2014/main" id="{80708F83-6FA7-447E-9527-8397EC139146}"/>
+                <a16:creationId xmlns:a16="http://schemas.microsoft.com/office/drawing/2014/main" id="{F028C4FB-780A-479F-A30F-889156B180BF}"/>
               </a:ext>
             </a:extLst>
           </p:cNvPr>
@@ -4957,7 +4957,7 @@
     </p:spTree>
     <p:extLst>
       <p:ext uri="{BB962C8B-B14F-4D97-AF65-F5344CB8AC3E}">
-        <p14:creationId xmlns:p14="http://schemas.microsoft.com/office/powerpoint/2010/main" val="1144943071"/>
+        <p14:creationId xmlns:p14="http://schemas.microsoft.com/office/powerpoint/2010/main" val="815723897"/>
       </p:ext>
     </p:extLst>
   </p:cSld>
@@ -4988,7 +4988,7 @@
           <p:cNvPr id="8" name="">
             <a:extLst xmlns:a="http://schemas.openxmlformats.org/drawingml/2006/main">
               <a:ext uri="{FF2B5EF4-FFF2-40B4-BE49-F238E27FC236}">
-                <a16:creationId xmlns:a16="http://schemas.microsoft.com/office/drawing/2014/main" id="{836C2711-47AC-4E33-9769-D31AB2766A83}"/>
+                <a16:creationId xmlns:a16="http://schemas.microsoft.com/office/drawing/2014/main" id="{87339309-C555-41AF-A692-D32CCE30DFCD}"/>
               </a:ext>
             </a:extLst>
           </p:cNvPr>
@@ -5056,7 +5056,7 @@
           <p:cNvPr id="2" name="">
             <a:extLst xmlns:a="http://schemas.openxmlformats.org/drawingml/2006/main">
               <a:ext uri="{FF2B5EF4-FFF2-40B4-BE49-F238E27FC236}">
-                <a16:creationId xmlns:a16="http://schemas.microsoft.com/office/drawing/2014/main" id="{5CF7D359-C4B8-4C43-B6CF-08963321E72A}"/>
+                <a16:creationId xmlns:a16="http://schemas.microsoft.com/office/drawing/2014/main" id="{2898A3EA-AC1A-46AB-B4E8-091C4F24FB96}"/>
               </a:ext>
             </a:extLst>
           </p:cNvPr>
@@ -5124,7 +5124,7 @@
           <p:cNvPr id="3" name="">
             <a:extLst xmlns:a="http://schemas.openxmlformats.org/drawingml/2006/main">
               <a:ext uri="{FF2B5EF4-FFF2-40B4-BE49-F238E27FC236}">
-                <a16:creationId xmlns:a16="http://schemas.microsoft.com/office/drawing/2014/main" id="{D1B6B13E-234F-46F2-A611-00ED8FD13D91}"/>
+                <a16:creationId xmlns:a16="http://schemas.microsoft.com/office/drawing/2014/main" id="{1B49A2A1-EADD-408F-8D8C-26131D424278}"/>
               </a:ext>
             </a:extLst>
           </p:cNvPr>
@@ -5154,7 +5154,7 @@
           <p:cNvPr id="4" name="">
             <a:extLst xmlns:a="http://schemas.openxmlformats.org/drawingml/2006/main">
               <a:ext uri="{FF2B5EF4-FFF2-40B4-BE49-F238E27FC236}">
-                <a16:creationId xmlns:a16="http://schemas.microsoft.com/office/drawing/2014/main" id="{20495E5D-E97D-4798-BE1B-1AD5F2260BF6}"/>
+                <a16:creationId xmlns:a16="http://schemas.microsoft.com/office/drawing/2014/main" id="{A30D7D97-EF5F-4AF1-AAA7-9F4A5C5EB980}"/>
               </a:ext>
             </a:extLst>
           </p:cNvPr>
@@ -5222,7 +5222,7 @@
           <p:cNvPr id="5" name="">
             <a:extLst xmlns:a="http://schemas.openxmlformats.org/drawingml/2006/main">
               <a:ext uri="{FF2B5EF4-FFF2-40B4-BE49-F238E27FC236}">
-                <a16:creationId xmlns:a16="http://schemas.microsoft.com/office/drawing/2014/main" id="{5BD0AE1B-FB72-4E2C-9FF4-24D63662E8D4}"/>
+                <a16:creationId xmlns:a16="http://schemas.microsoft.com/office/drawing/2014/main" id="{DAEE6491-D543-4F15-943F-E124D5FDAFB1}"/>
               </a:ext>
             </a:extLst>
           </p:cNvPr>
@@ -5290,7 +5290,7 @@
           <p:cNvPr id="6" name="">
             <a:extLst xmlns:a="http://schemas.openxmlformats.org/drawingml/2006/main">
               <a:ext uri="{FF2B5EF4-FFF2-40B4-BE49-F238E27FC236}">
-                <a16:creationId xmlns:a16="http://schemas.microsoft.com/office/drawing/2014/main" id="{37A19411-410C-42DE-B4AD-6142C26B8F8C}"/>
+                <a16:creationId xmlns:a16="http://schemas.microsoft.com/office/drawing/2014/main" id="{425A9DFB-AB48-47FC-87F8-39ACCE7FA2E8}"/>
               </a:ext>
             </a:extLst>
           </p:cNvPr>
@@ -6343,7 +6343,7 @@
           <p:cNvPr id="7" name="">
             <a:extLst xmlns:a="http://schemas.openxmlformats.org/drawingml/2006/main">
               <a:ext uri="{FF2B5EF4-FFF2-40B4-BE49-F238E27FC236}">
-                <a16:creationId xmlns:a16="http://schemas.microsoft.com/office/drawing/2014/main" id="{CD694B08-F20A-4D7A-B983-67B8A56CC3DB}"/>
+                <a16:creationId xmlns:a16="http://schemas.microsoft.com/office/drawing/2014/main" id="{4E4C09D3-C82A-49FD-8E34-AEFEC96722CD}"/>
               </a:ext>
             </a:extLst>
           </p:cNvPr>
@@ -6409,7 +6409,7 @@
     </p:spTree>
     <p:extLst>
       <p:ext uri="{BB962C8B-B14F-4D97-AF65-F5344CB8AC3E}">
-        <p14:creationId xmlns:p14="http://schemas.microsoft.com/office/powerpoint/2010/main" val="1967407803"/>
+        <p14:creationId xmlns:p14="http://schemas.microsoft.com/office/powerpoint/2010/main" val="154956822"/>
       </p:ext>
     </p:extLst>
   </p:cSld>
@@ -6440,7 +6440,7 @@
           <p:cNvPr id="11" name="">
             <a:extLst xmlns:a="http://schemas.openxmlformats.org/drawingml/2006/main">
               <a:ext uri="{FF2B5EF4-FFF2-40B4-BE49-F238E27FC236}">
-                <a16:creationId xmlns:a16="http://schemas.microsoft.com/office/drawing/2014/main" id="{C4EF4A92-54B3-4877-9A68-438BD8F6E7EB}"/>
+                <a16:creationId xmlns:a16="http://schemas.microsoft.com/office/drawing/2014/main" id="{A8EE3D1C-D122-4935-9AFF-46981EB8ADED}"/>
               </a:ext>
             </a:extLst>
           </p:cNvPr>
@@ -6508,7 +6508,7 @@
           <p:cNvPr id="2" name="">
             <a:extLst xmlns:a="http://schemas.openxmlformats.org/drawingml/2006/main">
               <a:ext uri="{FF2B5EF4-FFF2-40B4-BE49-F238E27FC236}">
-                <a16:creationId xmlns:a16="http://schemas.microsoft.com/office/drawing/2014/main" id="{16EB69B3-3D66-45C2-915C-20EAAC42DAA8}"/>
+                <a16:creationId xmlns:a16="http://schemas.microsoft.com/office/drawing/2014/main" id="{107437EF-5B25-40C3-BCC8-156218F387E2}"/>
               </a:ext>
             </a:extLst>
           </p:cNvPr>
@@ -6576,7 +6576,7 @@
           <p:cNvPr id="3" name="">
             <a:extLst xmlns:a="http://schemas.openxmlformats.org/drawingml/2006/main">
               <a:ext uri="{FF2B5EF4-FFF2-40B4-BE49-F238E27FC236}">
-                <a16:creationId xmlns:a16="http://schemas.microsoft.com/office/drawing/2014/main" id="{8B4DE0C3-FF66-4F82-995B-635DE06C11D0}"/>
+                <a16:creationId xmlns:a16="http://schemas.microsoft.com/office/drawing/2014/main" id="{3D3A5760-7D4E-48A1-BD90-0BE6C93688CC}"/>
               </a:ext>
             </a:extLst>
           </p:cNvPr>
@@ -6606,7 +6606,7 @@
           <p:cNvPr id="4" name="">
             <a:extLst xmlns:a="http://schemas.openxmlformats.org/drawingml/2006/main">
               <a:ext uri="{FF2B5EF4-FFF2-40B4-BE49-F238E27FC236}">
-                <a16:creationId xmlns:a16="http://schemas.microsoft.com/office/drawing/2014/main" id="{4897DC56-251B-4171-95D5-5407D97DFBE3}"/>
+                <a16:creationId xmlns:a16="http://schemas.microsoft.com/office/drawing/2014/main" id="{F3CB4E18-CA37-4650-B9D2-719A89399721}"/>
               </a:ext>
             </a:extLst>
           </p:cNvPr>
@@ -6674,7 +6674,7 @@
           <p:cNvPr id="5" name="">
             <a:extLst xmlns:a="http://schemas.openxmlformats.org/drawingml/2006/main">
               <a:ext uri="{FF2B5EF4-FFF2-40B4-BE49-F238E27FC236}">
-                <a16:creationId xmlns:a16="http://schemas.microsoft.com/office/drawing/2014/main" id="{31E17C73-183D-4490-B771-8DFC54B855EB}"/>
+                <a16:creationId xmlns:a16="http://schemas.microsoft.com/office/drawing/2014/main" id="{F6558776-B07C-4482-9F40-E26653ED5E00}"/>
               </a:ext>
             </a:extLst>
           </p:cNvPr>
@@ -6742,7 +6742,7 @@
           <p:cNvPr id="6" name="">
             <a:extLst xmlns:a="http://schemas.openxmlformats.org/drawingml/2006/main">
               <a:ext uri="{FF2B5EF4-FFF2-40B4-BE49-F238E27FC236}">
-                <a16:creationId xmlns:a16="http://schemas.microsoft.com/office/drawing/2014/main" id="{87D35540-E5BC-48C9-952B-6620F4D538CC}"/>
+                <a16:creationId xmlns:a16="http://schemas.microsoft.com/office/drawing/2014/main" id="{38B9548D-D2DC-469C-AA20-0B2D8F63BBBD}"/>
               </a:ext>
             </a:extLst>
           </p:cNvPr>
@@ -6810,7 +6810,7 @@
           <p:cNvPr id="7" name="">
             <a:extLst xmlns:a="http://schemas.openxmlformats.org/drawingml/2006/main">
               <a:ext uri="{FF2B5EF4-FFF2-40B4-BE49-F238E27FC236}">
-                <a16:creationId xmlns:a16="http://schemas.microsoft.com/office/drawing/2014/main" id="{69A5F0DD-402D-4B1D-AA78-B0FC4207DA9B}"/>
+                <a16:creationId xmlns:a16="http://schemas.microsoft.com/office/drawing/2014/main" id="{5802B56F-F002-4F76-8BA6-0BD5610DDBE1}"/>
               </a:ext>
             </a:extLst>
           </p:cNvPr>
@@ -6947,7 +6947,7 @@
           <p:cNvPr id="8" name="">
             <a:extLst xmlns:a="http://schemas.openxmlformats.org/drawingml/2006/main">
               <a:ext uri="{FF2B5EF4-FFF2-40B4-BE49-F238E27FC236}">
-                <a16:creationId xmlns:a16="http://schemas.microsoft.com/office/drawing/2014/main" id="{2B604A37-9B78-4A19-AEC8-CB340A8F39A5}"/>
+                <a16:creationId xmlns:a16="http://schemas.microsoft.com/office/drawing/2014/main" id="{87914814-9E9D-46E7-8AEB-B876C59447D6}"/>
               </a:ext>
             </a:extLst>
           </p:cNvPr>
@@ -7015,7 +7015,7 @@
           <p:cNvPr id="9" name="">
             <a:extLst xmlns:a="http://schemas.openxmlformats.org/drawingml/2006/main">
               <a:ext uri="{FF2B5EF4-FFF2-40B4-BE49-F238E27FC236}">
-                <a16:creationId xmlns:a16="http://schemas.microsoft.com/office/drawing/2014/main" id="{7664190F-4D51-49CF-9BCE-8A9192EA5ACB}"/>
+                <a16:creationId xmlns:a16="http://schemas.microsoft.com/office/drawing/2014/main" id="{CC0ACD31-C2CF-471F-AA6E-16BDB45C679C}"/>
               </a:ext>
             </a:extLst>
           </p:cNvPr>
@@ -7152,7 +7152,7 @@
           <p:cNvPr id="10" name="">
             <a:extLst xmlns:a="http://schemas.openxmlformats.org/drawingml/2006/main">
               <a:ext uri="{FF2B5EF4-FFF2-40B4-BE49-F238E27FC236}">
-                <a16:creationId xmlns:a16="http://schemas.microsoft.com/office/drawing/2014/main" id="{285E1077-1F05-4D12-BFC8-57BBDB5599D4}"/>
+                <a16:creationId xmlns:a16="http://schemas.microsoft.com/office/drawing/2014/main" id="{8FD9449F-AE40-479A-A105-99EAE109E712}"/>
               </a:ext>
             </a:extLst>
           </p:cNvPr>
@@ -7218,7 +7218,7 @@
     </p:spTree>
     <p:extLst>
       <p:ext uri="{BB962C8B-B14F-4D97-AF65-F5344CB8AC3E}">
-        <p14:creationId xmlns:p14="http://schemas.microsoft.com/office/powerpoint/2010/main" val="341293423"/>
+        <p14:creationId xmlns:p14="http://schemas.microsoft.com/office/powerpoint/2010/main" val="1081312466"/>
       </p:ext>
     </p:extLst>
   </p:cSld>
@@ -7249,7 +7249,7 @@
           <p:cNvPr id="11" name="">
             <a:extLst xmlns:a="http://schemas.openxmlformats.org/drawingml/2006/main">
               <a:ext uri="{FF2B5EF4-FFF2-40B4-BE49-F238E27FC236}">
-                <a16:creationId xmlns:a16="http://schemas.microsoft.com/office/drawing/2014/main" id="{4C731B2E-A948-4500-8E7E-4E9E3EF7224E}"/>
+                <a16:creationId xmlns:a16="http://schemas.microsoft.com/office/drawing/2014/main" id="{565FC0AB-F3D9-49D7-A2B3-C3DBAC5F8747}"/>
               </a:ext>
             </a:extLst>
           </p:cNvPr>
@@ -7317,7 +7317,7 @@
           <p:cNvPr id="2" name="">
             <a:extLst xmlns:a="http://schemas.openxmlformats.org/drawingml/2006/main">
               <a:ext uri="{FF2B5EF4-FFF2-40B4-BE49-F238E27FC236}">
-                <a16:creationId xmlns:a16="http://schemas.microsoft.com/office/drawing/2014/main" id="{C7E05CB6-46E5-4DB2-827E-6A94916C3413}"/>
+                <a16:creationId xmlns:a16="http://schemas.microsoft.com/office/drawing/2014/main" id="{F6A51B1D-3C87-4F65-B838-86385807A143}"/>
               </a:ext>
             </a:extLst>
           </p:cNvPr>
@@ -7385,7 +7385,7 @@
           <p:cNvPr id="3" name="">
             <a:extLst xmlns:a="http://schemas.openxmlformats.org/drawingml/2006/main">
               <a:ext uri="{FF2B5EF4-FFF2-40B4-BE49-F238E27FC236}">
-                <a16:creationId xmlns:a16="http://schemas.microsoft.com/office/drawing/2014/main" id="{FC3205F8-9EE4-4643-B4F8-6EED990EDEC0}"/>
+                <a16:creationId xmlns:a16="http://schemas.microsoft.com/office/drawing/2014/main" id="{DCD877B8-AA66-4C61-AB2C-A12ACF326469}"/>
               </a:ext>
             </a:extLst>
           </p:cNvPr>
@@ -7415,7 +7415,7 @@
           <p:cNvPr id="4" name="">
             <a:extLst xmlns:a="http://schemas.openxmlformats.org/drawingml/2006/main">
               <a:ext uri="{FF2B5EF4-FFF2-40B4-BE49-F238E27FC236}">
-                <a16:creationId xmlns:a16="http://schemas.microsoft.com/office/drawing/2014/main" id="{ABFBE4C2-56DD-4D63-995C-343634807C90}"/>
+                <a16:creationId xmlns:a16="http://schemas.microsoft.com/office/drawing/2014/main" id="{6F69F8B2-7D92-405A-86EA-6504380FBB6D}"/>
               </a:ext>
             </a:extLst>
           </p:cNvPr>
@@ -7483,7 +7483,7 @@
           <p:cNvPr id="5" name="">
             <a:extLst xmlns:a="http://schemas.openxmlformats.org/drawingml/2006/main">
               <a:ext uri="{FF2B5EF4-FFF2-40B4-BE49-F238E27FC236}">
-                <a16:creationId xmlns:a16="http://schemas.microsoft.com/office/drawing/2014/main" id="{ABD20B1B-55C7-412F-AC2F-7AAA9970BED8}"/>
+                <a16:creationId xmlns:a16="http://schemas.microsoft.com/office/drawing/2014/main" id="{738AB2B3-F8A1-4D60-859F-A10BBFBA4C38}"/>
               </a:ext>
             </a:extLst>
           </p:cNvPr>
@@ -7551,7 +7551,7 @@
           <p:cNvPr id="6" name="">
             <a:extLst xmlns:a="http://schemas.openxmlformats.org/drawingml/2006/main">
               <a:ext uri="{FF2B5EF4-FFF2-40B4-BE49-F238E27FC236}">
-                <a16:creationId xmlns:a16="http://schemas.microsoft.com/office/drawing/2014/main" id="{2C2631CD-DA0C-4457-B4D8-58ED5DCF1898}"/>
+                <a16:creationId xmlns:a16="http://schemas.microsoft.com/office/drawing/2014/main" id="{97623D51-DD7C-405E-8756-E3C3DC75B410}"/>
               </a:ext>
             </a:extLst>
           </p:cNvPr>
@@ -7619,7 +7619,7 @@
           <p:cNvPr id="7" name="">
             <a:extLst xmlns:a="http://schemas.openxmlformats.org/drawingml/2006/main">
               <a:ext uri="{FF2B5EF4-FFF2-40B4-BE49-F238E27FC236}">
-                <a16:creationId xmlns:a16="http://schemas.microsoft.com/office/drawing/2014/main" id="{56D8679C-18ED-467C-BAEB-D9C307B67935}"/>
+                <a16:creationId xmlns:a16="http://schemas.microsoft.com/office/drawing/2014/main" id="{EF090382-8C9E-4B4F-B37A-9E959E019B13}"/>
               </a:ext>
             </a:extLst>
           </p:cNvPr>
@@ -7687,7 +7687,7 @@
           <p:cNvPr id="8" name="">
             <a:extLst xmlns:a="http://schemas.openxmlformats.org/drawingml/2006/main">
               <a:ext uri="{FF2B5EF4-FFF2-40B4-BE49-F238E27FC236}">
-                <a16:creationId xmlns:a16="http://schemas.microsoft.com/office/drawing/2014/main" id="{59474034-A659-49EA-8D7E-A71BF42300B8}"/>
+                <a16:creationId xmlns:a16="http://schemas.microsoft.com/office/drawing/2014/main" id="{64E4F3D0-3960-426E-9C15-1910865DF5DF}"/>
               </a:ext>
             </a:extLst>
           </p:cNvPr>
@@ -7755,7 +7755,7 @@
           <p:cNvPr id="9" name="">
             <a:extLst xmlns:a="http://schemas.openxmlformats.org/drawingml/2006/main">
               <a:ext uri="{FF2B5EF4-FFF2-40B4-BE49-F238E27FC236}">
-                <a16:creationId xmlns:a16="http://schemas.microsoft.com/office/drawing/2014/main" id="{190FABB7-AD04-42D6-BC97-F4F88F028D73}"/>
+                <a16:creationId xmlns:a16="http://schemas.microsoft.com/office/drawing/2014/main" id="{CB4F03A1-12C9-4118-AE03-7691B8B13DBA}"/>
               </a:ext>
             </a:extLst>
           </p:cNvPr>
@@ -7823,7 +7823,7 @@
           <p:cNvPr id="10" name="">
             <a:extLst xmlns:a="http://schemas.openxmlformats.org/drawingml/2006/main">
               <a:ext uri="{FF2B5EF4-FFF2-40B4-BE49-F238E27FC236}">
-                <a16:creationId xmlns:a16="http://schemas.microsoft.com/office/drawing/2014/main" id="{CF5B5749-1677-4D66-975C-511A9061BCCD}"/>
+                <a16:creationId xmlns:a16="http://schemas.microsoft.com/office/drawing/2014/main" id="{CD6C727A-E568-4DE7-B947-9DC876CE5692}"/>
               </a:ext>
             </a:extLst>
           </p:cNvPr>
@@ -7889,7 +7889,7 @@
     </p:spTree>
     <p:extLst>
       <p:ext uri="{BB962C8B-B14F-4D97-AF65-F5344CB8AC3E}">
-        <p14:creationId xmlns:p14="http://schemas.microsoft.com/office/powerpoint/2010/main" val="1860012574"/>
+        <p14:creationId xmlns:p14="http://schemas.microsoft.com/office/powerpoint/2010/main" val="483483819"/>
       </p:ext>
     </p:extLst>
   </p:cSld>
@@ -7920,7 +7920,7 @@
           <p:cNvPr id="9" name="">
             <a:extLst xmlns:a="http://schemas.openxmlformats.org/drawingml/2006/main">
               <a:ext uri="{FF2B5EF4-FFF2-40B4-BE49-F238E27FC236}">
-                <a16:creationId xmlns:a16="http://schemas.microsoft.com/office/drawing/2014/main" id="{F8E827BB-E2AE-41A4-AECD-A01FF8781052}"/>
+                <a16:creationId xmlns:a16="http://schemas.microsoft.com/office/drawing/2014/main" id="{7E10CDC9-442D-47BE-8EB9-5B5E0E928D9E}"/>
               </a:ext>
             </a:extLst>
           </p:cNvPr>
@@ -7988,7 +7988,7 @@
           <p:cNvPr id="2" name="">
             <a:extLst xmlns:a="http://schemas.openxmlformats.org/drawingml/2006/main">
               <a:ext uri="{FF2B5EF4-FFF2-40B4-BE49-F238E27FC236}">
-                <a16:creationId xmlns:a16="http://schemas.microsoft.com/office/drawing/2014/main" id="{F76D6DDC-CEF0-47FF-9FD2-50BF88239D6F}"/>
+                <a16:creationId xmlns:a16="http://schemas.microsoft.com/office/drawing/2014/main" id="{2B9A6E90-7FCD-4477-A319-EA3AA63417A3}"/>
               </a:ext>
             </a:extLst>
           </p:cNvPr>
@@ -8056,7 +8056,7 @@
           <p:cNvPr id="3" name="">
             <a:extLst xmlns:a="http://schemas.openxmlformats.org/drawingml/2006/main">
               <a:ext uri="{FF2B5EF4-FFF2-40B4-BE49-F238E27FC236}">
-                <a16:creationId xmlns:a16="http://schemas.microsoft.com/office/drawing/2014/main" id="{810A6499-981C-4D4C-A365-4DD31D6C759E}"/>
+                <a16:creationId xmlns:a16="http://schemas.microsoft.com/office/drawing/2014/main" id="{BF2B9400-1BDC-4FC0-9869-89DD8F4BF7E6}"/>
               </a:ext>
             </a:extLst>
           </p:cNvPr>
@@ -8086,7 +8086,7 @@
           <p:cNvPr id="4" name="">
             <a:extLst xmlns:a="http://schemas.openxmlformats.org/drawingml/2006/main">
               <a:ext uri="{FF2B5EF4-FFF2-40B4-BE49-F238E27FC236}">
-                <a16:creationId xmlns:a16="http://schemas.microsoft.com/office/drawing/2014/main" id="{F149B338-27F3-442E-AF9F-36DD8982538B}"/>
+                <a16:creationId xmlns:a16="http://schemas.microsoft.com/office/drawing/2014/main" id="{8F3B1A43-61DD-4926-8BD1-3ABCB77BEE4C}"/>
               </a:ext>
             </a:extLst>
           </p:cNvPr>
@@ -8154,7 +8154,7 @@
           <p:cNvPr id="5" name="">
             <a:extLst xmlns:a="http://schemas.openxmlformats.org/drawingml/2006/main">
               <a:ext uri="{FF2B5EF4-FFF2-40B4-BE49-F238E27FC236}">
-                <a16:creationId xmlns:a16="http://schemas.microsoft.com/office/drawing/2014/main" id="{25631871-8626-4E8B-8556-8AA0BEFF0B88}"/>
+                <a16:creationId xmlns:a16="http://schemas.microsoft.com/office/drawing/2014/main" id="{A7EB2F7A-0A2E-435B-8979-63EA1DDE19DA}"/>
               </a:ext>
             </a:extLst>
           </p:cNvPr>
@@ -8222,7 +8222,7 @@
           <p:cNvPr id="6" name="Chart">
             <a:extLst xmlns:a="http://schemas.openxmlformats.org/drawingml/2006/main">
               <a:ext uri="{FF2B5EF4-FFF2-40B4-BE49-F238E27FC236}">
-                <a16:creationId xmlns:a16="http://schemas.microsoft.com/office/drawing/2014/main" id="{504A6C04-43F4-44E1-9402-72BDCC8A79D3}"/>
+                <a16:creationId xmlns:a16="http://schemas.microsoft.com/office/drawing/2014/main" id="{1F0FB355-F9F4-404C-9D52-8F2507C46EE8}"/>
               </a:ext>
             </a:extLst>
           </p:cNvPr>
@@ -8235,7 +8235,7 @@
         </p:xfrm>
         <a:graphic xmlns:a="http://schemas.openxmlformats.org/drawingml/2006/main">
           <a:graphicData uri="http://schemas.openxmlformats.org/drawingml/2006/chart">
-            <c:chart xmlns:r="http://schemas.openxmlformats.org/officeDocument/2006/relationships" xmlns:c="http://schemas.openxmlformats.org/drawingml/2006/chart" r:id="R6b1cd2e609f54d4c"/>
+            <c:chart xmlns:r="http://schemas.openxmlformats.org/officeDocument/2006/relationships" xmlns:c="http://schemas.openxmlformats.org/drawingml/2006/chart" r:id="R05419c0ecc65437b"/>
           </a:graphicData>
         </a:graphic>
       </p:graphicFrame>
@@ -8244,7 +8244,7 @@
           <p:cNvPr id="7" name="">
             <a:extLst xmlns:a="http://schemas.openxmlformats.org/drawingml/2006/main">
               <a:ext uri="{FF2B5EF4-FFF2-40B4-BE49-F238E27FC236}">
-                <a16:creationId xmlns:a16="http://schemas.microsoft.com/office/drawing/2014/main" id="{F5C08003-1686-4A03-8567-E6AFBFC4A513}"/>
+                <a16:creationId xmlns:a16="http://schemas.microsoft.com/office/drawing/2014/main" id="{2B7882B1-C53E-4DDA-AD0D-983E74028A7C}"/>
               </a:ext>
             </a:extLst>
           </p:cNvPr>
@@ -8312,7 +8312,7 @@
           <p:cNvPr id="8" name="">
             <a:extLst xmlns:a="http://schemas.openxmlformats.org/drawingml/2006/main">
               <a:ext uri="{FF2B5EF4-FFF2-40B4-BE49-F238E27FC236}">
-                <a16:creationId xmlns:a16="http://schemas.microsoft.com/office/drawing/2014/main" id="{C4E46690-C891-4CF6-8C52-96FDCC362A05}"/>
+                <a16:creationId xmlns:a16="http://schemas.microsoft.com/office/drawing/2014/main" id="{82E441F0-EBF0-492F-9B05-8E1E1D843410}"/>
               </a:ext>
             </a:extLst>
           </p:cNvPr>
@@ -8378,7 +8378,7 @@
     </p:spTree>
     <p:extLst>
       <p:ext uri="{BB962C8B-B14F-4D97-AF65-F5344CB8AC3E}">
-        <p14:creationId xmlns:p14="http://schemas.microsoft.com/office/powerpoint/2010/main" val="2107755277"/>
+        <p14:creationId xmlns:p14="http://schemas.microsoft.com/office/powerpoint/2010/main" val="1821967455"/>
       </p:ext>
     </p:extLst>
   </p:cSld>
@@ -8409,7 +8409,7 @@
           <p:cNvPr id="25" name="">
             <a:extLst xmlns:a="http://schemas.openxmlformats.org/drawingml/2006/main">
               <a:ext uri="{FF2B5EF4-FFF2-40B4-BE49-F238E27FC236}">
-                <a16:creationId xmlns:a16="http://schemas.microsoft.com/office/drawing/2014/main" id="{884C978A-5E94-4E92-9240-E8DE9C24198F}"/>
+                <a16:creationId xmlns:a16="http://schemas.microsoft.com/office/drawing/2014/main" id="{BE783720-A3E6-4CBA-A685-1D54A157B23C}"/>
               </a:ext>
             </a:extLst>
           </p:cNvPr>
@@ -8477,7 +8477,7 @@
           <p:cNvPr id="2" name="">
             <a:extLst xmlns:a="http://schemas.openxmlformats.org/drawingml/2006/main">
               <a:ext uri="{FF2B5EF4-FFF2-40B4-BE49-F238E27FC236}">
-                <a16:creationId xmlns:a16="http://schemas.microsoft.com/office/drawing/2014/main" id="{041C73C0-EC83-44AF-A189-18E6D5E10352}"/>
+                <a16:creationId xmlns:a16="http://schemas.microsoft.com/office/drawing/2014/main" id="{95CC09EB-D9A9-487F-AB6E-971BCF62DA45}"/>
               </a:ext>
             </a:extLst>
           </p:cNvPr>
@@ -8545,7 +8545,7 @@
           <p:cNvPr id="3" name="">
             <a:extLst xmlns:a="http://schemas.openxmlformats.org/drawingml/2006/main">
               <a:ext uri="{FF2B5EF4-FFF2-40B4-BE49-F238E27FC236}">
-                <a16:creationId xmlns:a16="http://schemas.microsoft.com/office/drawing/2014/main" id="{6AD7B7C8-5125-4F19-8E23-AB91DA5A6802}"/>
+                <a16:creationId xmlns:a16="http://schemas.microsoft.com/office/drawing/2014/main" id="{86CC9C5D-AFDD-4D86-8EA9-4FD841CAF9F4}"/>
               </a:ext>
             </a:extLst>
           </p:cNvPr>
@@ -8575,7 +8575,7 @@
           <p:cNvPr id="4" name="">
             <a:extLst xmlns:a="http://schemas.openxmlformats.org/drawingml/2006/main">
               <a:ext uri="{FF2B5EF4-FFF2-40B4-BE49-F238E27FC236}">
-                <a16:creationId xmlns:a16="http://schemas.microsoft.com/office/drawing/2014/main" id="{D297C565-CD2A-4EFC-819B-EE9ABD9C09B2}"/>
+                <a16:creationId xmlns:a16="http://schemas.microsoft.com/office/drawing/2014/main" id="{760C073B-5467-4F9C-A15D-825296064CC7}"/>
               </a:ext>
             </a:extLst>
           </p:cNvPr>
@@ -8643,7 +8643,7 @@
           <p:cNvPr id="5" name="">
             <a:extLst xmlns:a="http://schemas.openxmlformats.org/drawingml/2006/main">
               <a:ext uri="{FF2B5EF4-FFF2-40B4-BE49-F238E27FC236}">
-                <a16:creationId xmlns:a16="http://schemas.microsoft.com/office/drawing/2014/main" id="{1E46EAC1-49FE-4754-B022-05CBA383813B}"/>
+                <a16:creationId xmlns:a16="http://schemas.microsoft.com/office/drawing/2014/main" id="{824EEF52-B224-4A32-A256-D6F04C3B8D2D}"/>
               </a:ext>
             </a:extLst>
           </p:cNvPr>
@@ -8711,7 +8711,7 @@
           <p:cNvPr id="6" name="">
             <a:extLst xmlns:a="http://schemas.openxmlformats.org/drawingml/2006/main">
               <a:ext uri="{FF2B5EF4-FFF2-40B4-BE49-F238E27FC236}">
-                <a16:creationId xmlns:a16="http://schemas.microsoft.com/office/drawing/2014/main" id="{9F4FCEE8-FE82-445F-8674-6CF018F0C5CB}"/>
+                <a16:creationId xmlns:a16="http://schemas.microsoft.com/office/drawing/2014/main" id="{4B50293E-73F9-428C-A291-043FDC449B4B}"/>
               </a:ext>
             </a:extLst>
           </p:cNvPr>
@@ -8779,7 +8779,7 @@
           <p:cNvPr id="7" name="">
             <a:extLst xmlns:a="http://schemas.openxmlformats.org/drawingml/2006/main">
               <a:ext uri="{FF2B5EF4-FFF2-40B4-BE49-F238E27FC236}">
-                <a16:creationId xmlns:a16="http://schemas.microsoft.com/office/drawing/2014/main" id="{CB03AAF0-2CC5-4B93-B763-37A3BF010E9C}"/>
+                <a16:creationId xmlns:a16="http://schemas.microsoft.com/office/drawing/2014/main" id="{23E3F483-8031-4F41-B24C-3A56A8C48DC7}"/>
               </a:ext>
             </a:extLst>
           </p:cNvPr>
@@ -8847,7 +8847,7 @@
           <p:cNvPr id="8" name="">
             <a:extLst xmlns:a="http://schemas.openxmlformats.org/drawingml/2006/main">
               <a:ext uri="{FF2B5EF4-FFF2-40B4-BE49-F238E27FC236}">
-                <a16:creationId xmlns:a16="http://schemas.microsoft.com/office/drawing/2014/main" id="{13C6C2FC-7307-4232-883C-A610BFAACAE0}"/>
+                <a16:creationId xmlns:a16="http://schemas.microsoft.com/office/drawing/2014/main" id="{55AA79A4-9855-4FFB-8074-5F532C58CD08}"/>
               </a:ext>
             </a:extLst>
           </p:cNvPr>
@@ -8915,7 +8915,7 @@
           <p:cNvPr id="9" name="">
             <a:extLst xmlns:a="http://schemas.openxmlformats.org/drawingml/2006/main">
               <a:ext uri="{FF2B5EF4-FFF2-40B4-BE49-F238E27FC236}">
-                <a16:creationId xmlns:a16="http://schemas.microsoft.com/office/drawing/2014/main" id="{DD418803-1764-4463-99C2-242DE2F8CAA9}"/>
+                <a16:creationId xmlns:a16="http://schemas.microsoft.com/office/drawing/2014/main" id="{21EB7944-0F12-43A9-9F2D-5A769AD3C328}"/>
               </a:ext>
             </a:extLst>
           </p:cNvPr>
@@ -8983,7 +8983,7 @@
           <p:cNvPr id="10" name="">
             <a:extLst xmlns:a="http://schemas.openxmlformats.org/drawingml/2006/main">
               <a:ext uri="{FF2B5EF4-FFF2-40B4-BE49-F238E27FC236}">
-                <a16:creationId xmlns:a16="http://schemas.microsoft.com/office/drawing/2014/main" id="{056FD11B-F66B-4E1D-9FC7-81EBC4C56705}"/>
+                <a16:creationId xmlns:a16="http://schemas.microsoft.com/office/drawing/2014/main" id="{2E8B8F6C-BEA3-45B3-AD78-B6E862DF6995}"/>
               </a:ext>
             </a:extLst>
           </p:cNvPr>
@@ -9051,7 +9051,7 @@
           <p:cNvPr id="11" name="">
             <a:extLst xmlns:a="http://schemas.openxmlformats.org/drawingml/2006/main">
               <a:ext uri="{FF2B5EF4-FFF2-40B4-BE49-F238E27FC236}">
-                <a16:creationId xmlns:a16="http://schemas.microsoft.com/office/drawing/2014/main" id="{96EC62B3-2453-438C-88FC-B2A0F694AAEC}"/>
+                <a16:creationId xmlns:a16="http://schemas.microsoft.com/office/drawing/2014/main" id="{68055F98-0E47-483F-BBA0-BACB26AAF88E}"/>
               </a:ext>
             </a:extLst>
           </p:cNvPr>
@@ -9119,7 +9119,7 @@
           <p:cNvPr id="12" name="">
             <a:extLst xmlns:a="http://schemas.openxmlformats.org/drawingml/2006/main">
               <a:ext uri="{FF2B5EF4-FFF2-40B4-BE49-F238E27FC236}">
-                <a16:creationId xmlns:a16="http://schemas.microsoft.com/office/drawing/2014/main" id="{0F102906-4563-490D-A24B-6109C08EFF9B}"/>
+                <a16:creationId xmlns:a16="http://schemas.microsoft.com/office/drawing/2014/main" id="{C73192AA-7589-477A-A2C7-453A7A82D090}"/>
               </a:ext>
             </a:extLst>
           </p:cNvPr>
@@ -9187,7 +9187,7 @@
           <p:cNvPr id="13" name="">
             <a:extLst xmlns:a="http://schemas.openxmlformats.org/drawingml/2006/main">
               <a:ext uri="{FF2B5EF4-FFF2-40B4-BE49-F238E27FC236}">
-                <a16:creationId xmlns:a16="http://schemas.microsoft.com/office/drawing/2014/main" id="{2AF04EC1-094E-41A2-9DAB-8C6C0C027D3F}"/>
+                <a16:creationId xmlns:a16="http://schemas.microsoft.com/office/drawing/2014/main" id="{8A79D269-8CAF-4D1A-ACCC-DB39CD95BCB0}"/>
               </a:ext>
             </a:extLst>
           </p:cNvPr>
@@ -9255,7 +9255,7 @@
           <p:cNvPr id="14" name="">
             <a:extLst xmlns:a="http://schemas.openxmlformats.org/drawingml/2006/main">
               <a:ext uri="{FF2B5EF4-FFF2-40B4-BE49-F238E27FC236}">
-                <a16:creationId xmlns:a16="http://schemas.microsoft.com/office/drawing/2014/main" id="{EE7937FD-3651-4B18-806E-4854E6251CF0}"/>
+                <a16:creationId xmlns:a16="http://schemas.microsoft.com/office/drawing/2014/main" id="{9F8D7027-08C0-4E30-9C77-3EEA5CB3EA77}"/>
               </a:ext>
             </a:extLst>
           </p:cNvPr>
@@ -9323,7 +9323,7 @@
           <p:cNvPr id="15" name="">
             <a:extLst xmlns:a="http://schemas.openxmlformats.org/drawingml/2006/main">
               <a:ext uri="{FF2B5EF4-FFF2-40B4-BE49-F238E27FC236}">
-                <a16:creationId xmlns:a16="http://schemas.microsoft.com/office/drawing/2014/main" id="{7D9B9BDF-5CFE-49AA-BAA5-222B404E3402}"/>
+                <a16:creationId xmlns:a16="http://schemas.microsoft.com/office/drawing/2014/main" id="{07BD04B4-4501-423B-A7A7-849057764417}"/>
               </a:ext>
             </a:extLst>
           </p:cNvPr>
@@ -9391,7 +9391,7 @@
           <p:cNvPr id="16" name="">
             <a:extLst xmlns:a="http://schemas.openxmlformats.org/drawingml/2006/main">
               <a:ext uri="{FF2B5EF4-FFF2-40B4-BE49-F238E27FC236}">
-                <a16:creationId xmlns:a16="http://schemas.microsoft.com/office/drawing/2014/main" id="{E8FA8575-DA32-4C81-9B31-597661D971D1}"/>
+                <a16:creationId xmlns:a16="http://schemas.microsoft.com/office/drawing/2014/main" id="{BB9219FC-16D4-4696-8080-20AC46CB83B3}"/>
               </a:ext>
             </a:extLst>
           </p:cNvPr>
@@ -9459,7 +9459,7 @@
           <p:cNvPr id="17" name="">
             <a:extLst xmlns:a="http://schemas.openxmlformats.org/drawingml/2006/main">
               <a:ext uri="{FF2B5EF4-FFF2-40B4-BE49-F238E27FC236}">
-                <a16:creationId xmlns:a16="http://schemas.microsoft.com/office/drawing/2014/main" id="{8DF393ED-BC5A-4B7F-8A61-6339848299DB}"/>
+                <a16:creationId xmlns:a16="http://schemas.microsoft.com/office/drawing/2014/main" id="{828A14CD-788D-4B2F-B675-32DBC4927F7A}"/>
               </a:ext>
             </a:extLst>
           </p:cNvPr>
@@ -9527,7 +9527,7 @@
           <p:cNvPr id="18" name="">
             <a:extLst xmlns:a="http://schemas.openxmlformats.org/drawingml/2006/main">
               <a:ext uri="{FF2B5EF4-FFF2-40B4-BE49-F238E27FC236}">
-                <a16:creationId xmlns:a16="http://schemas.microsoft.com/office/drawing/2014/main" id="{AEDA6186-1E02-4F24-BCF8-7C15A2824387}"/>
+                <a16:creationId xmlns:a16="http://schemas.microsoft.com/office/drawing/2014/main" id="{FF76EDAA-F6A9-4CB4-B164-530A6215D271}"/>
               </a:ext>
             </a:extLst>
           </p:cNvPr>
@@ -9595,7 +9595,7 @@
           <p:cNvPr id="19" name="">
             <a:extLst xmlns:a="http://schemas.openxmlformats.org/drawingml/2006/main">
               <a:ext uri="{FF2B5EF4-FFF2-40B4-BE49-F238E27FC236}">
-                <a16:creationId xmlns:a16="http://schemas.microsoft.com/office/drawing/2014/main" id="{9C3C82EE-9222-46DB-B2F2-7447E031D4BD}"/>
+                <a16:creationId xmlns:a16="http://schemas.microsoft.com/office/drawing/2014/main" id="{7D69300E-4199-48A8-B376-1AE1B300A3C8}"/>
               </a:ext>
             </a:extLst>
           </p:cNvPr>
@@ -9663,7 +9663,7 @@
           <p:cNvPr id="20" name="">
             <a:extLst xmlns:a="http://schemas.openxmlformats.org/drawingml/2006/main">
               <a:ext uri="{FF2B5EF4-FFF2-40B4-BE49-F238E27FC236}">
-                <a16:creationId xmlns:a16="http://schemas.microsoft.com/office/drawing/2014/main" id="{7A9FC760-16BC-4C34-81C2-E3DD0EF5F3F8}"/>
+                <a16:creationId xmlns:a16="http://schemas.microsoft.com/office/drawing/2014/main" id="{B32408A5-808E-4418-99AE-744284F75C8B}"/>
               </a:ext>
             </a:extLst>
           </p:cNvPr>
@@ -9731,7 +9731,7 @@
           <p:cNvPr id="21" name="">
             <a:extLst xmlns:a="http://schemas.openxmlformats.org/drawingml/2006/main">
               <a:ext uri="{FF2B5EF4-FFF2-40B4-BE49-F238E27FC236}">
-                <a16:creationId xmlns:a16="http://schemas.microsoft.com/office/drawing/2014/main" id="{4982845C-5291-47DB-A872-CF739356FAAA}"/>
+                <a16:creationId xmlns:a16="http://schemas.microsoft.com/office/drawing/2014/main" id="{A9D8F8F6-DF3B-45BE-9CAA-BE18BA5621CF}"/>
               </a:ext>
             </a:extLst>
           </p:cNvPr>
@@ -9799,7 +9799,7 @@
           <p:cNvPr id="22" name="">
             <a:extLst xmlns:a="http://schemas.openxmlformats.org/drawingml/2006/main">
               <a:ext uri="{FF2B5EF4-FFF2-40B4-BE49-F238E27FC236}">
-                <a16:creationId xmlns:a16="http://schemas.microsoft.com/office/drawing/2014/main" id="{F43D01A6-EE28-4B0F-B424-7F9D84832F59}"/>
+                <a16:creationId xmlns:a16="http://schemas.microsoft.com/office/drawing/2014/main" id="{3E8720A6-F039-4EF4-A930-7978AA926650}"/>
               </a:ext>
             </a:extLst>
           </p:cNvPr>
@@ -9867,7 +9867,7 @@
           <p:cNvPr id="23" name="">
             <a:extLst xmlns:a="http://schemas.openxmlformats.org/drawingml/2006/main">
               <a:ext uri="{FF2B5EF4-FFF2-40B4-BE49-F238E27FC236}">
-                <a16:creationId xmlns:a16="http://schemas.microsoft.com/office/drawing/2014/main" id="{92D951E2-A9F6-4222-9CD7-5A4F71E7E674}"/>
+                <a16:creationId xmlns:a16="http://schemas.microsoft.com/office/drawing/2014/main" id="{60BDCD12-148C-406C-AF15-ED9C8FC0E1D4}"/>
               </a:ext>
             </a:extLst>
           </p:cNvPr>
@@ -9935,7 +9935,7 @@
           <p:cNvPr id="24" name="">
             <a:extLst xmlns:a="http://schemas.openxmlformats.org/drawingml/2006/main">
               <a:ext uri="{FF2B5EF4-FFF2-40B4-BE49-F238E27FC236}">
-                <a16:creationId xmlns:a16="http://schemas.microsoft.com/office/drawing/2014/main" id="{9C2B5662-C7AB-47D1-8BE6-EE891535E647}"/>
+                <a16:creationId xmlns:a16="http://schemas.microsoft.com/office/drawing/2014/main" id="{522FBF87-AD0A-479A-A45D-E817C129882B}"/>
               </a:ext>
             </a:extLst>
           </p:cNvPr>
@@ -9993,7 +9993,7 @@
                 <a:ea typeface="Arial"/>
                 <a:cs typeface="Arial"/>
               </a:rPr>
-              <a:t>Software quality: 244 passing tests; predictive results remain separate.</a:t>
+              <a:t>Software quality: 246 passing tests; predictive results remain separate.</a:t>
             </a:r>
           </a:p>
         </p:txBody>
@@ -10001,7 +10001,7 @@
     </p:spTree>
     <p:extLst>
       <p:ext uri="{BB962C8B-B14F-4D97-AF65-F5344CB8AC3E}">
-        <p14:creationId xmlns:p14="http://schemas.microsoft.com/office/powerpoint/2010/main" val="1529502095"/>
+        <p14:creationId xmlns:p14="http://schemas.microsoft.com/office/powerpoint/2010/main" val="263191551"/>
       </p:ext>
     </p:extLst>
   </p:cSld>
@@ -10032,7 +10032,7 @@
           <p:cNvPr id="11" name="">
             <a:extLst xmlns:a="http://schemas.openxmlformats.org/drawingml/2006/main">
               <a:ext uri="{FF2B5EF4-FFF2-40B4-BE49-F238E27FC236}">
-                <a16:creationId xmlns:a16="http://schemas.microsoft.com/office/drawing/2014/main" id="{A1EF6AFC-C3BC-44FC-BBC0-2D3B0E225D49}"/>
+                <a16:creationId xmlns:a16="http://schemas.microsoft.com/office/drawing/2014/main" id="{A686EB56-576B-4FB4-B8AB-9DD11CE4BF08}"/>
               </a:ext>
             </a:extLst>
           </p:cNvPr>
@@ -10100,7 +10100,7 @@
           <p:cNvPr id="2" name="">
             <a:extLst xmlns:a="http://schemas.openxmlformats.org/drawingml/2006/main">
               <a:ext uri="{FF2B5EF4-FFF2-40B4-BE49-F238E27FC236}">
-                <a16:creationId xmlns:a16="http://schemas.microsoft.com/office/drawing/2014/main" id="{BB2D68D2-D40F-4C76-BD26-F27AAA37E215}"/>
+                <a16:creationId xmlns:a16="http://schemas.microsoft.com/office/drawing/2014/main" id="{83518D82-70E4-41C8-A877-A0F6BBFA1211}"/>
               </a:ext>
             </a:extLst>
           </p:cNvPr>
@@ -10168,7 +10168,7 @@
           <p:cNvPr id="3" name="">
             <a:extLst xmlns:a="http://schemas.openxmlformats.org/drawingml/2006/main">
               <a:ext uri="{FF2B5EF4-FFF2-40B4-BE49-F238E27FC236}">
-                <a16:creationId xmlns:a16="http://schemas.microsoft.com/office/drawing/2014/main" id="{0B21A083-5DF3-481C-8985-D9498FCFB0B1}"/>
+                <a16:creationId xmlns:a16="http://schemas.microsoft.com/office/drawing/2014/main" id="{0DE21E12-81AB-49B0-8662-719C3EA02CD0}"/>
               </a:ext>
             </a:extLst>
           </p:cNvPr>
@@ -10198,7 +10198,7 @@
           <p:cNvPr id="4" name="">
             <a:extLst xmlns:a="http://schemas.openxmlformats.org/drawingml/2006/main">
               <a:ext uri="{FF2B5EF4-FFF2-40B4-BE49-F238E27FC236}">
-                <a16:creationId xmlns:a16="http://schemas.microsoft.com/office/drawing/2014/main" id="{EA3A834A-F7B2-4949-BBC3-791AA18C78FE}"/>
+                <a16:creationId xmlns:a16="http://schemas.microsoft.com/office/drawing/2014/main" id="{5E2C9BC5-BDEF-4A1E-9968-067D16D3763E}"/>
               </a:ext>
             </a:extLst>
           </p:cNvPr>
@@ -10266,7 +10266,7 @@
           <p:cNvPr id="5" name="">
             <a:extLst xmlns:a="http://schemas.openxmlformats.org/drawingml/2006/main">
               <a:ext uri="{FF2B5EF4-FFF2-40B4-BE49-F238E27FC236}">
-                <a16:creationId xmlns:a16="http://schemas.microsoft.com/office/drawing/2014/main" id="{E1B62285-F3EB-441F-9A48-0C856ABED6EA}"/>
+                <a16:creationId xmlns:a16="http://schemas.microsoft.com/office/drawing/2014/main" id="{028A509A-1E21-44D2-849C-FCA2D7DDDC51}"/>
               </a:ext>
             </a:extLst>
           </p:cNvPr>
@@ -10334,7 +10334,7 @@
           <p:cNvPr id="6" name="">
             <a:extLst xmlns:a="http://schemas.openxmlformats.org/drawingml/2006/main">
               <a:ext uri="{FF2B5EF4-FFF2-40B4-BE49-F238E27FC236}">
-                <a16:creationId xmlns:a16="http://schemas.microsoft.com/office/drawing/2014/main" id="{AA066BB1-C95B-48AF-962E-0AF11F63CD3C}"/>
+                <a16:creationId xmlns:a16="http://schemas.microsoft.com/office/drawing/2014/main" id="{512A5760-D053-4329-BD5C-1555CD6AD917}"/>
               </a:ext>
             </a:extLst>
           </p:cNvPr>
@@ -10402,7 +10402,7 @@
           <p:cNvPr id="7" name="">
             <a:extLst xmlns:a="http://schemas.openxmlformats.org/drawingml/2006/main">
               <a:ext uri="{FF2B5EF4-FFF2-40B4-BE49-F238E27FC236}">
-                <a16:creationId xmlns:a16="http://schemas.microsoft.com/office/drawing/2014/main" id="{CDC0DA04-F3D4-4AF0-9D65-41C37A91699F}"/>
+                <a16:creationId xmlns:a16="http://schemas.microsoft.com/office/drawing/2014/main" id="{895F80F9-AD4D-41E2-9BA6-93369B68C042}"/>
               </a:ext>
             </a:extLst>
           </p:cNvPr>
@@ -10539,7 +10539,7 @@
           <p:cNvPr id="8" name="">
             <a:extLst xmlns:a="http://schemas.openxmlformats.org/drawingml/2006/main">
               <a:ext uri="{FF2B5EF4-FFF2-40B4-BE49-F238E27FC236}">
-                <a16:creationId xmlns:a16="http://schemas.microsoft.com/office/drawing/2014/main" id="{DF48A424-6E3F-4404-A0FA-F8F13874CC4C}"/>
+                <a16:creationId xmlns:a16="http://schemas.microsoft.com/office/drawing/2014/main" id="{DAC451F1-9B2F-4640-A3E5-0D89214E15C1}"/>
               </a:ext>
             </a:extLst>
           </p:cNvPr>
@@ -10607,7 +10607,7 @@
           <p:cNvPr id="9" name="">
             <a:extLst xmlns:a="http://schemas.openxmlformats.org/drawingml/2006/main">
               <a:ext uri="{FF2B5EF4-FFF2-40B4-BE49-F238E27FC236}">
-                <a16:creationId xmlns:a16="http://schemas.microsoft.com/office/drawing/2014/main" id="{AE45793B-B653-49D7-B10D-F706B91B32B8}"/>
+                <a16:creationId xmlns:a16="http://schemas.microsoft.com/office/drawing/2014/main" id="{4CC981D2-4E59-4B59-AD6E-1763BCBA1273}"/>
               </a:ext>
             </a:extLst>
           </p:cNvPr>
@@ -10744,7 +10744,7 @@
           <p:cNvPr id="10" name="">
             <a:extLst xmlns:a="http://schemas.openxmlformats.org/drawingml/2006/main">
               <a:ext uri="{FF2B5EF4-FFF2-40B4-BE49-F238E27FC236}">
-                <a16:creationId xmlns:a16="http://schemas.microsoft.com/office/drawing/2014/main" id="{2EC4D82A-866D-44BC-823A-82EA46D82AF3}"/>
+                <a16:creationId xmlns:a16="http://schemas.microsoft.com/office/drawing/2014/main" id="{ED3B88FC-B234-4E05-A8AC-01D0CD314CAA}"/>
               </a:ext>
             </a:extLst>
           </p:cNvPr>
@@ -10810,7 +10810,7 @@
     </p:spTree>
     <p:extLst>
       <p:ext uri="{BB962C8B-B14F-4D97-AF65-F5344CB8AC3E}">
-        <p14:creationId xmlns:p14="http://schemas.microsoft.com/office/powerpoint/2010/main" val="1728990594"/>
+        <p14:creationId xmlns:p14="http://schemas.microsoft.com/office/powerpoint/2010/main" val="465623537"/>
       </p:ext>
     </p:extLst>
   </p:cSld>
@@ -10841,7 +10841,7 @@
           <p:cNvPr id="11" name="">
             <a:extLst xmlns:a="http://schemas.openxmlformats.org/drawingml/2006/main">
               <a:ext uri="{FF2B5EF4-FFF2-40B4-BE49-F238E27FC236}">
-                <a16:creationId xmlns:a16="http://schemas.microsoft.com/office/drawing/2014/main" id="{6411640E-2620-4775-AFDC-0D82B3D9D82A}"/>
+                <a16:creationId xmlns:a16="http://schemas.microsoft.com/office/drawing/2014/main" id="{CACBFF9B-F17E-4019-9128-E77C35E339DE}"/>
               </a:ext>
             </a:extLst>
           </p:cNvPr>
@@ -10909,7 +10909,7 @@
           <p:cNvPr id="2" name="">
             <a:extLst xmlns:a="http://schemas.openxmlformats.org/drawingml/2006/main">
               <a:ext uri="{FF2B5EF4-FFF2-40B4-BE49-F238E27FC236}">
-                <a16:creationId xmlns:a16="http://schemas.microsoft.com/office/drawing/2014/main" id="{342AEA2E-A8F9-4EF9-A4DD-C531C8D67FA0}"/>
+                <a16:creationId xmlns:a16="http://schemas.microsoft.com/office/drawing/2014/main" id="{E7A1D18E-F9FF-4691-B8C7-7402985938C0}"/>
               </a:ext>
             </a:extLst>
           </p:cNvPr>
@@ -10977,7 +10977,7 @@
           <p:cNvPr id="3" name="">
             <a:extLst xmlns:a="http://schemas.openxmlformats.org/drawingml/2006/main">
               <a:ext uri="{FF2B5EF4-FFF2-40B4-BE49-F238E27FC236}">
-                <a16:creationId xmlns:a16="http://schemas.microsoft.com/office/drawing/2014/main" id="{EB6DEF40-9E80-4EC4-8D43-E7EB8AD927EE}"/>
+                <a16:creationId xmlns:a16="http://schemas.microsoft.com/office/drawing/2014/main" id="{256E3524-D82B-4247-9EE2-B4D7EDFDB4F8}"/>
               </a:ext>
             </a:extLst>
           </p:cNvPr>
@@ -11007,7 +11007,7 @@
           <p:cNvPr id="4" name="">
             <a:extLst xmlns:a="http://schemas.openxmlformats.org/drawingml/2006/main">
               <a:ext uri="{FF2B5EF4-FFF2-40B4-BE49-F238E27FC236}">
-                <a16:creationId xmlns:a16="http://schemas.microsoft.com/office/drawing/2014/main" id="{0D5D97C6-41B1-4F72-B6E1-9235D8E12DF6}"/>
+                <a16:creationId xmlns:a16="http://schemas.microsoft.com/office/drawing/2014/main" id="{63AC8088-0C77-44DF-B60D-81837516B5D8}"/>
               </a:ext>
             </a:extLst>
           </p:cNvPr>
@@ -11075,7 +11075,7 @@
           <p:cNvPr id="5" name="">
             <a:extLst xmlns:a="http://schemas.openxmlformats.org/drawingml/2006/main">
               <a:ext uri="{FF2B5EF4-FFF2-40B4-BE49-F238E27FC236}">
-                <a16:creationId xmlns:a16="http://schemas.microsoft.com/office/drawing/2014/main" id="{62CB0CFE-8B0C-48E6-8356-3A87473D0524}"/>
+                <a16:creationId xmlns:a16="http://schemas.microsoft.com/office/drawing/2014/main" id="{8F446825-31BA-4736-BFB2-0035F0FA0722}"/>
               </a:ext>
             </a:extLst>
           </p:cNvPr>
@@ -11143,7 +11143,7 @@
           <p:cNvPr id="6" name="">
             <a:extLst xmlns:a="http://schemas.openxmlformats.org/drawingml/2006/main">
               <a:ext uri="{FF2B5EF4-FFF2-40B4-BE49-F238E27FC236}">
-                <a16:creationId xmlns:a16="http://schemas.microsoft.com/office/drawing/2014/main" id="{F5546F4B-42EA-425D-93AF-C7D66396308E}"/>
+                <a16:creationId xmlns:a16="http://schemas.microsoft.com/office/drawing/2014/main" id="{8074C253-2028-436F-BC87-4970C4F544D9}"/>
               </a:ext>
             </a:extLst>
           </p:cNvPr>
@@ -11211,7 +11211,7 @@
           <p:cNvPr id="7" name="">
             <a:extLst xmlns:a="http://schemas.openxmlformats.org/drawingml/2006/main">
               <a:ext uri="{FF2B5EF4-FFF2-40B4-BE49-F238E27FC236}">
-                <a16:creationId xmlns:a16="http://schemas.microsoft.com/office/drawing/2014/main" id="{AE7C52C3-1631-4F65-8436-3C6822059618}"/>
+                <a16:creationId xmlns:a16="http://schemas.microsoft.com/office/drawing/2014/main" id="{B9877E78-99B7-4FDF-B92C-731D2DCDC0BA}"/>
               </a:ext>
             </a:extLst>
           </p:cNvPr>
@@ -11348,7 +11348,7 @@
           <p:cNvPr id="8" name="">
             <a:extLst xmlns:a="http://schemas.openxmlformats.org/drawingml/2006/main">
               <a:ext uri="{FF2B5EF4-FFF2-40B4-BE49-F238E27FC236}">
-                <a16:creationId xmlns:a16="http://schemas.microsoft.com/office/drawing/2014/main" id="{1CC74BA1-4F46-495F-8E92-A96680E83495}"/>
+                <a16:creationId xmlns:a16="http://schemas.microsoft.com/office/drawing/2014/main" id="{46FA8191-D93E-44B2-A731-0E7E1DE00100}"/>
               </a:ext>
             </a:extLst>
           </p:cNvPr>
@@ -11416,7 +11416,7 @@
           <p:cNvPr id="9" name="">
             <a:extLst xmlns:a="http://schemas.openxmlformats.org/drawingml/2006/main">
               <a:ext uri="{FF2B5EF4-FFF2-40B4-BE49-F238E27FC236}">
-                <a16:creationId xmlns:a16="http://schemas.microsoft.com/office/drawing/2014/main" id="{5B8311A2-A10D-420C-909C-0B2BD9C87362}"/>
+                <a16:creationId xmlns:a16="http://schemas.microsoft.com/office/drawing/2014/main" id="{A2E3DD8D-E574-4BBE-B48B-C52E98F1AD35}"/>
               </a:ext>
             </a:extLst>
           </p:cNvPr>
@@ -11553,7 +11553,7 @@
           <p:cNvPr id="10" name="">
             <a:extLst xmlns:a="http://schemas.openxmlformats.org/drawingml/2006/main">
               <a:ext uri="{FF2B5EF4-FFF2-40B4-BE49-F238E27FC236}">
-                <a16:creationId xmlns:a16="http://schemas.microsoft.com/office/drawing/2014/main" id="{FB210B85-3C92-452B-9047-5DB1A1A16ED4}"/>
+                <a16:creationId xmlns:a16="http://schemas.microsoft.com/office/drawing/2014/main" id="{21444BB3-08B6-4B65-BD17-6DE010A5AC71}"/>
               </a:ext>
             </a:extLst>
           </p:cNvPr>
@@ -11619,7 +11619,7 @@
     </p:spTree>
     <p:extLst>
       <p:ext uri="{BB962C8B-B14F-4D97-AF65-F5344CB8AC3E}">
-        <p14:creationId xmlns:p14="http://schemas.microsoft.com/office/powerpoint/2010/main" val="1746834051"/>
+        <p14:creationId xmlns:p14="http://schemas.microsoft.com/office/powerpoint/2010/main" val="793945028"/>
       </p:ext>
     </p:extLst>
   </p:cSld>
@@ -11650,7 +11650,7 @@
           <p:cNvPr id="14" name="">
             <a:extLst xmlns:a="http://schemas.openxmlformats.org/drawingml/2006/main">
               <a:ext uri="{FF2B5EF4-FFF2-40B4-BE49-F238E27FC236}">
-                <a16:creationId xmlns:a16="http://schemas.microsoft.com/office/drawing/2014/main" id="{D7397E6D-81B4-4877-BCAD-DD5799A387DA}"/>
+                <a16:creationId xmlns:a16="http://schemas.microsoft.com/office/drawing/2014/main" id="{1E6A47B1-8BD3-47AB-AE6F-F10B0930F804}"/>
               </a:ext>
             </a:extLst>
           </p:cNvPr>
@@ -11718,7 +11718,7 @@
           <p:cNvPr id="2" name="">
             <a:extLst xmlns:a="http://schemas.openxmlformats.org/drawingml/2006/main">
               <a:ext uri="{FF2B5EF4-FFF2-40B4-BE49-F238E27FC236}">
-                <a16:creationId xmlns:a16="http://schemas.microsoft.com/office/drawing/2014/main" id="{004F8B8E-9C8D-4464-BBF8-2CA3FEAD2844}"/>
+                <a16:creationId xmlns:a16="http://schemas.microsoft.com/office/drawing/2014/main" id="{448B911B-85A0-427B-8526-257B8D07B76A}"/>
               </a:ext>
             </a:extLst>
           </p:cNvPr>
@@ -11786,7 +11786,7 @@
           <p:cNvPr id="3" name="">
             <a:extLst xmlns:a="http://schemas.openxmlformats.org/drawingml/2006/main">
               <a:ext uri="{FF2B5EF4-FFF2-40B4-BE49-F238E27FC236}">
-                <a16:creationId xmlns:a16="http://schemas.microsoft.com/office/drawing/2014/main" id="{2D36FADE-5A00-469C-B73A-87B087EC926D}"/>
+                <a16:creationId xmlns:a16="http://schemas.microsoft.com/office/drawing/2014/main" id="{9C8013D8-C14A-4DF7-926F-BCFEBE16FD32}"/>
               </a:ext>
             </a:extLst>
           </p:cNvPr>
@@ -11816,7 +11816,7 @@
           <p:cNvPr id="4" name="">
             <a:extLst xmlns:a="http://schemas.openxmlformats.org/drawingml/2006/main">
               <a:ext uri="{FF2B5EF4-FFF2-40B4-BE49-F238E27FC236}">
-                <a16:creationId xmlns:a16="http://schemas.microsoft.com/office/drawing/2014/main" id="{D8F4AB18-2338-4DAD-8131-5E39EFDA8F3C}"/>
+                <a16:creationId xmlns:a16="http://schemas.microsoft.com/office/drawing/2014/main" id="{FBBC6612-0C71-41C2-959A-B2D80999E205}"/>
               </a:ext>
             </a:extLst>
           </p:cNvPr>
@@ -11884,7 +11884,7 @@
           <p:cNvPr id="5" name="">
             <a:extLst xmlns:a="http://schemas.openxmlformats.org/drawingml/2006/main">
               <a:ext uri="{FF2B5EF4-FFF2-40B4-BE49-F238E27FC236}">
-                <a16:creationId xmlns:a16="http://schemas.microsoft.com/office/drawing/2014/main" id="{B7ADDD7A-6B84-4C3F-BF17-ECFCDADC8BF6}"/>
+                <a16:creationId xmlns:a16="http://schemas.microsoft.com/office/drawing/2014/main" id="{7E16FA16-132F-4D16-B4F5-AAF8CC36368D}"/>
               </a:ext>
             </a:extLst>
           </p:cNvPr>
@@ -11952,7 +11952,7 @@
           <p:cNvPr id="6" name="">
             <a:extLst xmlns:a="http://schemas.openxmlformats.org/drawingml/2006/main">
               <a:ext uri="{FF2B5EF4-FFF2-40B4-BE49-F238E27FC236}">
-                <a16:creationId xmlns:a16="http://schemas.microsoft.com/office/drawing/2014/main" id="{9430E858-29D8-4D16-B4E9-AF94B9E63C45}"/>
+                <a16:creationId xmlns:a16="http://schemas.microsoft.com/office/drawing/2014/main" id="{1C4891BA-1AE9-470F-9BF2-3ABDC68224F7}"/>
               </a:ext>
             </a:extLst>
           </p:cNvPr>
@@ -12020,7 +12020,7 @@
           <p:cNvPr id="7" name="">
             <a:extLst xmlns:a="http://schemas.openxmlformats.org/drawingml/2006/main">
               <a:ext uri="{FF2B5EF4-FFF2-40B4-BE49-F238E27FC236}">
-                <a16:creationId xmlns:a16="http://schemas.microsoft.com/office/drawing/2014/main" id="{2540D9A5-4C20-4EC0-8578-C3D9DF10E397}"/>
+                <a16:creationId xmlns:a16="http://schemas.microsoft.com/office/drawing/2014/main" id="{B916F2EE-985B-4393-B122-81D6BAE0F24C}"/>
               </a:ext>
             </a:extLst>
           </p:cNvPr>
@@ -12088,7 +12088,7 @@
           <p:cNvPr id="8" name="">
             <a:extLst xmlns:a="http://schemas.openxmlformats.org/drawingml/2006/main">
               <a:ext uri="{FF2B5EF4-FFF2-40B4-BE49-F238E27FC236}">
-                <a16:creationId xmlns:a16="http://schemas.microsoft.com/office/drawing/2014/main" id="{3D093825-F64C-4222-8455-782984E6F7BC}"/>
+                <a16:creationId xmlns:a16="http://schemas.microsoft.com/office/drawing/2014/main" id="{251E652F-EE43-4F06-B1AC-8DC64C9CAC4D}"/>
               </a:ext>
             </a:extLst>
           </p:cNvPr>
@@ -12156,7 +12156,7 @@
           <p:cNvPr id="9" name="">
             <a:extLst xmlns:a="http://schemas.openxmlformats.org/drawingml/2006/main">
               <a:ext uri="{FF2B5EF4-FFF2-40B4-BE49-F238E27FC236}">
-                <a16:creationId xmlns:a16="http://schemas.microsoft.com/office/drawing/2014/main" id="{E7F01D73-A89A-4D44-9FAD-025869FFE6A0}"/>
+                <a16:creationId xmlns:a16="http://schemas.microsoft.com/office/drawing/2014/main" id="{89B1A2B4-3BA9-4E12-869D-AC544D51BD4F}"/>
               </a:ext>
             </a:extLst>
           </p:cNvPr>
@@ -12224,7 +12224,7 @@
           <p:cNvPr id="10" name="">
             <a:extLst xmlns:a="http://schemas.openxmlformats.org/drawingml/2006/main">
               <a:ext uri="{FF2B5EF4-FFF2-40B4-BE49-F238E27FC236}">
-                <a16:creationId xmlns:a16="http://schemas.microsoft.com/office/drawing/2014/main" id="{81ECC90E-4820-4F02-92D3-904C0B128E14}"/>
+                <a16:creationId xmlns:a16="http://schemas.microsoft.com/office/drawing/2014/main" id="{DD26DA96-1F6D-4735-AD32-6E23A117950D}"/>
               </a:ext>
             </a:extLst>
           </p:cNvPr>
@@ -12292,7 +12292,7 @@
           <p:cNvPr id="11" name="">
             <a:extLst xmlns:a="http://schemas.openxmlformats.org/drawingml/2006/main">
               <a:ext uri="{FF2B5EF4-FFF2-40B4-BE49-F238E27FC236}">
-                <a16:creationId xmlns:a16="http://schemas.microsoft.com/office/drawing/2014/main" id="{F6F5503F-556C-4588-A75B-ED39A24740A4}"/>
+                <a16:creationId xmlns:a16="http://schemas.microsoft.com/office/drawing/2014/main" id="{DA540034-7920-457B-BC0F-F026E18AEB79}"/>
               </a:ext>
             </a:extLst>
           </p:cNvPr>
@@ -12360,7 +12360,7 @@
           <p:cNvPr id="12" name="">
             <a:extLst xmlns:a="http://schemas.openxmlformats.org/drawingml/2006/main">
               <a:ext uri="{FF2B5EF4-FFF2-40B4-BE49-F238E27FC236}">
-                <a16:creationId xmlns:a16="http://schemas.microsoft.com/office/drawing/2014/main" id="{D19A1477-C663-4094-A2CA-1458203BF21D}"/>
+                <a16:creationId xmlns:a16="http://schemas.microsoft.com/office/drawing/2014/main" id="{0A539326-B495-47F0-8758-9AF7AD412498}"/>
               </a:ext>
             </a:extLst>
           </p:cNvPr>
@@ -12428,7 +12428,7 @@
           <p:cNvPr id="13" name="">
             <a:extLst xmlns:a="http://schemas.openxmlformats.org/drawingml/2006/main">
               <a:ext uri="{FF2B5EF4-FFF2-40B4-BE49-F238E27FC236}">
-                <a16:creationId xmlns:a16="http://schemas.microsoft.com/office/drawing/2014/main" id="{31839593-14FB-425F-9DF3-820E8C70E77F}"/>
+                <a16:creationId xmlns:a16="http://schemas.microsoft.com/office/drawing/2014/main" id="{72E88A25-84E2-4C1E-B9E3-3FB9AE9FC107}"/>
               </a:ext>
             </a:extLst>
           </p:cNvPr>
@@ -12494,7 +12494,7 @@
     </p:spTree>
     <p:extLst>
       <p:ext uri="{BB962C8B-B14F-4D97-AF65-F5344CB8AC3E}">
-        <p14:creationId xmlns:p14="http://schemas.microsoft.com/office/powerpoint/2010/main" val="1882572042"/>
+        <p14:creationId xmlns:p14="http://schemas.microsoft.com/office/powerpoint/2010/main" val="351996241"/>
       </p:ext>
     </p:extLst>
   </p:cSld>
@@ -12525,7 +12525,7 @@
           <p:cNvPr id="11" name="">
             <a:extLst xmlns:a="http://schemas.openxmlformats.org/drawingml/2006/main">
               <a:ext uri="{FF2B5EF4-FFF2-40B4-BE49-F238E27FC236}">
-                <a16:creationId xmlns:a16="http://schemas.microsoft.com/office/drawing/2014/main" id="{1555B4C7-9ABB-4628-9A9F-BC6B43A1CF07}"/>
+                <a16:creationId xmlns:a16="http://schemas.microsoft.com/office/drawing/2014/main" id="{C6FC584D-DCB7-419A-B15F-4B8FD3ED41A5}"/>
               </a:ext>
             </a:extLst>
           </p:cNvPr>
@@ -12593,7 +12593,7 @@
           <p:cNvPr id="2" name="">
             <a:extLst xmlns:a="http://schemas.openxmlformats.org/drawingml/2006/main">
               <a:ext uri="{FF2B5EF4-FFF2-40B4-BE49-F238E27FC236}">
-                <a16:creationId xmlns:a16="http://schemas.microsoft.com/office/drawing/2014/main" id="{50E2D795-6312-4264-B2A5-0A0C72EEDB34}"/>
+                <a16:creationId xmlns:a16="http://schemas.microsoft.com/office/drawing/2014/main" id="{B1AF4E1C-1050-4280-A2AC-E4A4E4DF9F20}"/>
               </a:ext>
             </a:extLst>
           </p:cNvPr>
@@ -12661,7 +12661,7 @@
           <p:cNvPr id="3" name="">
             <a:extLst xmlns:a="http://schemas.openxmlformats.org/drawingml/2006/main">
               <a:ext uri="{FF2B5EF4-FFF2-40B4-BE49-F238E27FC236}">
-                <a16:creationId xmlns:a16="http://schemas.microsoft.com/office/drawing/2014/main" id="{255A1192-FAF0-4383-BA46-6CE41F76BE9F}"/>
+                <a16:creationId xmlns:a16="http://schemas.microsoft.com/office/drawing/2014/main" id="{342D1F83-BB8F-4276-9059-1D217FB3E814}"/>
               </a:ext>
             </a:extLst>
           </p:cNvPr>
@@ -12691,7 +12691,7 @@
           <p:cNvPr id="4" name="">
             <a:extLst xmlns:a="http://schemas.openxmlformats.org/drawingml/2006/main">
               <a:ext uri="{FF2B5EF4-FFF2-40B4-BE49-F238E27FC236}">
-                <a16:creationId xmlns:a16="http://schemas.microsoft.com/office/drawing/2014/main" id="{D598FC75-6663-46A0-9AC3-783EAF41B790}"/>
+                <a16:creationId xmlns:a16="http://schemas.microsoft.com/office/drawing/2014/main" id="{4621E0E1-5A34-46D5-B690-2BBBEE639985}"/>
               </a:ext>
             </a:extLst>
           </p:cNvPr>
@@ -12759,7 +12759,7 @@
           <p:cNvPr id="5" name="">
             <a:extLst xmlns:a="http://schemas.openxmlformats.org/drawingml/2006/main">
               <a:ext uri="{FF2B5EF4-FFF2-40B4-BE49-F238E27FC236}">
-                <a16:creationId xmlns:a16="http://schemas.microsoft.com/office/drawing/2014/main" id="{5819C53E-5C9D-4AD1-B419-DFACC3A4904D}"/>
+                <a16:creationId xmlns:a16="http://schemas.microsoft.com/office/drawing/2014/main" id="{AD866024-554A-470C-9CD3-3055F16CECAE}"/>
               </a:ext>
             </a:extLst>
           </p:cNvPr>
@@ -12827,7 +12827,7 @@
           <p:cNvPr id="6" name="">
             <a:extLst xmlns:a="http://schemas.openxmlformats.org/drawingml/2006/main">
               <a:ext uri="{FF2B5EF4-FFF2-40B4-BE49-F238E27FC236}">
-                <a16:creationId xmlns:a16="http://schemas.microsoft.com/office/drawing/2014/main" id="{6811D646-F952-4F2A-BA8E-E14654F4E398}"/>
+                <a16:creationId xmlns:a16="http://schemas.microsoft.com/office/drawing/2014/main" id="{04B78A7B-3A8B-4748-A460-F136DC05E4B3}"/>
               </a:ext>
             </a:extLst>
           </p:cNvPr>
@@ -12895,7 +12895,7 @@
           <p:cNvPr id="7" name="">
             <a:extLst xmlns:a="http://schemas.openxmlformats.org/drawingml/2006/main">
               <a:ext uri="{FF2B5EF4-FFF2-40B4-BE49-F238E27FC236}">
-                <a16:creationId xmlns:a16="http://schemas.microsoft.com/office/drawing/2014/main" id="{5C584196-B1D1-41AE-850E-3FA3754C5D89}"/>
+                <a16:creationId xmlns:a16="http://schemas.microsoft.com/office/drawing/2014/main" id="{F381B018-7E10-4839-AA60-FF6367EA5588}"/>
               </a:ext>
             </a:extLst>
           </p:cNvPr>
@@ -12963,7 +12963,7 @@
           <p:cNvPr id="8" name="">
             <a:extLst xmlns:a="http://schemas.openxmlformats.org/drawingml/2006/main">
               <a:ext uri="{FF2B5EF4-FFF2-40B4-BE49-F238E27FC236}">
-                <a16:creationId xmlns:a16="http://schemas.microsoft.com/office/drawing/2014/main" id="{C571200B-43EB-4B3E-8EE4-B3C3F4712EB6}"/>
+                <a16:creationId xmlns:a16="http://schemas.microsoft.com/office/drawing/2014/main" id="{09E3965B-DD0C-436B-B4D2-A531DD3A39F4}"/>
               </a:ext>
             </a:extLst>
           </p:cNvPr>
@@ -13031,7 +13031,7 @@
           <p:cNvPr id="9" name="">
             <a:extLst xmlns:a="http://schemas.openxmlformats.org/drawingml/2006/main">
               <a:ext uri="{FF2B5EF4-FFF2-40B4-BE49-F238E27FC236}">
-                <a16:creationId xmlns:a16="http://schemas.microsoft.com/office/drawing/2014/main" id="{52E43ED2-C30B-49F4-B566-095C5FAA33E7}"/>
+                <a16:creationId xmlns:a16="http://schemas.microsoft.com/office/drawing/2014/main" id="{451B609E-BE9F-4133-AAD1-5B96569E5043}"/>
               </a:ext>
             </a:extLst>
           </p:cNvPr>
@@ -13099,7 +13099,7 @@
           <p:cNvPr id="10" name="">
             <a:extLst xmlns:a="http://schemas.openxmlformats.org/drawingml/2006/main">
               <a:ext uri="{FF2B5EF4-FFF2-40B4-BE49-F238E27FC236}">
-                <a16:creationId xmlns:a16="http://schemas.microsoft.com/office/drawing/2014/main" id="{E9AE2D69-72CD-435F-B1A7-BE4EBC3B1EDF}"/>
+                <a16:creationId xmlns:a16="http://schemas.microsoft.com/office/drawing/2014/main" id="{96D889BE-1DC3-4542-99C3-382BFD49968E}"/>
               </a:ext>
             </a:extLst>
           </p:cNvPr>
@@ -13165,7 +13165,7 @@
     </p:spTree>
     <p:extLst>
       <p:ext uri="{BB962C8B-B14F-4D97-AF65-F5344CB8AC3E}">
-        <p14:creationId xmlns:p14="http://schemas.microsoft.com/office/powerpoint/2010/main" val="815763720"/>
+        <p14:creationId xmlns:p14="http://schemas.microsoft.com/office/powerpoint/2010/main" val="907916580"/>
       </p:ext>
     </p:extLst>
   </p:cSld>
@@ -13196,7 +13196,7 @@
           <p:cNvPr id="11" name="">
             <a:extLst xmlns:a="http://schemas.openxmlformats.org/drawingml/2006/main">
               <a:ext uri="{FF2B5EF4-FFF2-40B4-BE49-F238E27FC236}">
-                <a16:creationId xmlns:a16="http://schemas.microsoft.com/office/drawing/2014/main" id="{4C66A63C-1393-4B92-8BC8-BE538F50CC39}"/>
+                <a16:creationId xmlns:a16="http://schemas.microsoft.com/office/drawing/2014/main" id="{86881CAF-EBF0-47CF-83D1-37C1C7D61378}"/>
               </a:ext>
             </a:extLst>
           </p:cNvPr>
@@ -13264,7 +13264,7 @@
           <p:cNvPr id="2" name="">
             <a:extLst xmlns:a="http://schemas.openxmlformats.org/drawingml/2006/main">
               <a:ext uri="{FF2B5EF4-FFF2-40B4-BE49-F238E27FC236}">
-                <a16:creationId xmlns:a16="http://schemas.microsoft.com/office/drawing/2014/main" id="{46B64BFB-9889-411E-92DA-F0479CA4798D}"/>
+                <a16:creationId xmlns:a16="http://schemas.microsoft.com/office/drawing/2014/main" id="{DB59CF9B-8974-454D-BF3E-77599DF02AA3}"/>
               </a:ext>
             </a:extLst>
           </p:cNvPr>
@@ -13332,7 +13332,7 @@
           <p:cNvPr id="3" name="">
             <a:extLst xmlns:a="http://schemas.openxmlformats.org/drawingml/2006/main">
               <a:ext uri="{FF2B5EF4-FFF2-40B4-BE49-F238E27FC236}">
-                <a16:creationId xmlns:a16="http://schemas.microsoft.com/office/drawing/2014/main" id="{7C2B71A1-3F01-41CF-96CD-53B07BD05682}"/>
+                <a16:creationId xmlns:a16="http://schemas.microsoft.com/office/drawing/2014/main" id="{4E8A9AD9-5FB8-45B7-82E6-562EE24945D4}"/>
               </a:ext>
             </a:extLst>
           </p:cNvPr>
@@ -13362,7 +13362,7 @@
           <p:cNvPr id="4" name="">
             <a:extLst xmlns:a="http://schemas.openxmlformats.org/drawingml/2006/main">
               <a:ext uri="{FF2B5EF4-FFF2-40B4-BE49-F238E27FC236}">
-                <a16:creationId xmlns:a16="http://schemas.microsoft.com/office/drawing/2014/main" id="{D42BDCA9-AB07-4E9B-945E-858C818392F0}"/>
+                <a16:creationId xmlns:a16="http://schemas.microsoft.com/office/drawing/2014/main" id="{59D23CB9-EF40-4BB7-B826-9048164F68AC}"/>
               </a:ext>
             </a:extLst>
           </p:cNvPr>
@@ -13430,7 +13430,7 @@
           <p:cNvPr id="5" name="">
             <a:extLst xmlns:a="http://schemas.openxmlformats.org/drawingml/2006/main">
               <a:ext uri="{FF2B5EF4-FFF2-40B4-BE49-F238E27FC236}">
-                <a16:creationId xmlns:a16="http://schemas.microsoft.com/office/drawing/2014/main" id="{9957698E-4553-41B3-A357-0D099ED50F87}"/>
+                <a16:creationId xmlns:a16="http://schemas.microsoft.com/office/drawing/2014/main" id="{3357C380-B556-48A7-B31F-3A618305CB19}"/>
               </a:ext>
             </a:extLst>
           </p:cNvPr>
@@ -13498,7 +13498,7 @@
           <p:cNvPr id="6" name="">
             <a:extLst xmlns:a="http://schemas.openxmlformats.org/drawingml/2006/main">
               <a:ext uri="{FF2B5EF4-FFF2-40B4-BE49-F238E27FC236}">
-                <a16:creationId xmlns:a16="http://schemas.microsoft.com/office/drawing/2014/main" id="{F6A69DA3-3224-47A5-8A68-0DAD04458B1B}"/>
+                <a16:creationId xmlns:a16="http://schemas.microsoft.com/office/drawing/2014/main" id="{EBB55254-FC16-405F-9275-8B1C523B14E2}"/>
               </a:ext>
             </a:extLst>
           </p:cNvPr>
@@ -13566,7 +13566,7 @@
           <p:cNvPr id="7" name="">
             <a:extLst xmlns:a="http://schemas.openxmlformats.org/drawingml/2006/main">
               <a:ext uri="{FF2B5EF4-FFF2-40B4-BE49-F238E27FC236}">
-                <a16:creationId xmlns:a16="http://schemas.microsoft.com/office/drawing/2014/main" id="{52840964-4A6A-4BE2-A13A-8A81EBC66C3B}"/>
+                <a16:creationId xmlns:a16="http://schemas.microsoft.com/office/drawing/2014/main" id="{DFE3D2AC-49A9-4005-8856-9B1C5676FFE9}"/>
               </a:ext>
             </a:extLst>
           </p:cNvPr>
@@ -13634,7 +13634,7 @@
           <p:cNvPr id="8" name="">
             <a:extLst xmlns:a="http://schemas.openxmlformats.org/drawingml/2006/main">
               <a:ext uri="{FF2B5EF4-FFF2-40B4-BE49-F238E27FC236}">
-                <a16:creationId xmlns:a16="http://schemas.microsoft.com/office/drawing/2014/main" id="{C8BFC3BD-7270-4500-A0CB-FF1883386DBB}"/>
+                <a16:creationId xmlns:a16="http://schemas.microsoft.com/office/drawing/2014/main" id="{B3EC4B8E-AD97-4FEC-A065-750F64C4C730}"/>
               </a:ext>
             </a:extLst>
           </p:cNvPr>
@@ -13748,7 +13748,7 @@
           <p:cNvPr id="9" name="Chart">
             <a:extLst xmlns:a="http://schemas.openxmlformats.org/drawingml/2006/main">
               <a:ext uri="{FF2B5EF4-FFF2-40B4-BE49-F238E27FC236}">
-                <a16:creationId xmlns:a16="http://schemas.microsoft.com/office/drawing/2014/main" id="{2625DA1F-8CCE-430C-BFC7-D40DE9C4222E}"/>
+                <a16:creationId xmlns:a16="http://schemas.microsoft.com/office/drawing/2014/main" id="{D5B8DAA9-4FF5-4C43-8063-A9727B3C4589}"/>
               </a:ext>
             </a:extLst>
           </p:cNvPr>
@@ -13761,7 +13761,7 @@
         </p:xfrm>
         <a:graphic xmlns:a="http://schemas.openxmlformats.org/drawingml/2006/main">
           <a:graphicData uri="http://schemas.openxmlformats.org/drawingml/2006/chart">
-            <c:chart xmlns:r="http://schemas.openxmlformats.org/officeDocument/2006/relationships" xmlns:c="http://schemas.openxmlformats.org/drawingml/2006/chart" r:id="Rb008cf2676d241e3"/>
+            <c:chart xmlns:r="http://schemas.openxmlformats.org/officeDocument/2006/relationships" xmlns:c="http://schemas.openxmlformats.org/drawingml/2006/chart" r:id="R50a8d4840bfc43b7"/>
           </a:graphicData>
         </a:graphic>
       </p:graphicFrame>
@@ -13770,7 +13770,7 @@
           <p:cNvPr id="10" name="">
             <a:extLst xmlns:a="http://schemas.openxmlformats.org/drawingml/2006/main">
               <a:ext uri="{FF2B5EF4-FFF2-40B4-BE49-F238E27FC236}">
-                <a16:creationId xmlns:a16="http://schemas.microsoft.com/office/drawing/2014/main" id="{F1A3DF96-075E-405B-BA86-C3064969E49F}"/>
+                <a16:creationId xmlns:a16="http://schemas.microsoft.com/office/drawing/2014/main" id="{DEBA50B3-0AE8-4AE8-BD15-9E761CF1D534}"/>
               </a:ext>
             </a:extLst>
           </p:cNvPr>
@@ -13836,7 +13836,7 @@
     </p:spTree>
     <p:extLst>
       <p:ext uri="{BB962C8B-B14F-4D97-AF65-F5344CB8AC3E}">
-        <p14:creationId xmlns:p14="http://schemas.microsoft.com/office/powerpoint/2010/main" val="1699281226"/>
+        <p14:creationId xmlns:p14="http://schemas.microsoft.com/office/powerpoint/2010/main" val="28408646"/>
       </p:ext>
     </p:extLst>
   </p:cSld>
@@ -13867,7 +13867,7 @@
           <p:cNvPr id="26" name="">
             <a:extLst xmlns:a="http://schemas.openxmlformats.org/drawingml/2006/main">
               <a:ext uri="{FF2B5EF4-FFF2-40B4-BE49-F238E27FC236}">
-                <a16:creationId xmlns:a16="http://schemas.microsoft.com/office/drawing/2014/main" id="{89C65A69-2B8A-4FA5-B7EA-934A8A7B6722}"/>
+                <a16:creationId xmlns:a16="http://schemas.microsoft.com/office/drawing/2014/main" id="{888E4550-0E10-4404-8741-9FD9E300F163}"/>
               </a:ext>
             </a:extLst>
           </p:cNvPr>
@@ -13935,7 +13935,7 @@
           <p:cNvPr id="2" name="">
             <a:extLst xmlns:a="http://schemas.openxmlformats.org/drawingml/2006/main">
               <a:ext uri="{FF2B5EF4-FFF2-40B4-BE49-F238E27FC236}">
-                <a16:creationId xmlns:a16="http://schemas.microsoft.com/office/drawing/2014/main" id="{9C11AF16-44F9-42A0-862D-27C2871C11A9}"/>
+                <a16:creationId xmlns:a16="http://schemas.microsoft.com/office/drawing/2014/main" id="{30A4D619-BB4A-4840-9ED9-9ABE8A7F6C7A}"/>
               </a:ext>
             </a:extLst>
           </p:cNvPr>
@@ -14003,7 +14003,7 @@
           <p:cNvPr id="3" name="">
             <a:extLst xmlns:a="http://schemas.openxmlformats.org/drawingml/2006/main">
               <a:ext uri="{FF2B5EF4-FFF2-40B4-BE49-F238E27FC236}">
-                <a16:creationId xmlns:a16="http://schemas.microsoft.com/office/drawing/2014/main" id="{4831AC74-1E7D-48DF-A5CA-919E72C03EBF}"/>
+                <a16:creationId xmlns:a16="http://schemas.microsoft.com/office/drawing/2014/main" id="{37DC4D68-A62D-4046-BD46-8EEAE95EF0FA}"/>
               </a:ext>
             </a:extLst>
           </p:cNvPr>
@@ -14033,7 +14033,7 @@
           <p:cNvPr id="4" name="">
             <a:extLst xmlns:a="http://schemas.openxmlformats.org/drawingml/2006/main">
               <a:ext uri="{FF2B5EF4-FFF2-40B4-BE49-F238E27FC236}">
-                <a16:creationId xmlns:a16="http://schemas.microsoft.com/office/drawing/2014/main" id="{7358959E-7341-49AB-9DB2-E4ADCFDDC3E6}"/>
+                <a16:creationId xmlns:a16="http://schemas.microsoft.com/office/drawing/2014/main" id="{BC5C4D08-4340-40D7-89A3-C9647941DD8B}"/>
               </a:ext>
             </a:extLst>
           </p:cNvPr>
@@ -14101,7 +14101,7 @@
           <p:cNvPr id="5" name="">
             <a:extLst xmlns:a="http://schemas.openxmlformats.org/drawingml/2006/main">
               <a:ext uri="{FF2B5EF4-FFF2-40B4-BE49-F238E27FC236}">
-                <a16:creationId xmlns:a16="http://schemas.microsoft.com/office/drawing/2014/main" id="{F230E329-FC58-424B-92D3-B16003C46A93}"/>
+                <a16:creationId xmlns:a16="http://schemas.microsoft.com/office/drawing/2014/main" id="{06F1D346-E305-4A56-9F84-8CEEBBA9686E}"/>
               </a:ext>
             </a:extLst>
           </p:cNvPr>
@@ -14169,7 +14169,7 @@
           <p:cNvPr id="6" name="">
             <a:extLst xmlns:a="http://schemas.openxmlformats.org/drawingml/2006/main">
               <a:ext uri="{FF2B5EF4-FFF2-40B4-BE49-F238E27FC236}">
-                <a16:creationId xmlns:a16="http://schemas.microsoft.com/office/drawing/2014/main" id="{340A91C8-7890-4173-9506-C1142DC7F332}"/>
+                <a16:creationId xmlns:a16="http://schemas.microsoft.com/office/drawing/2014/main" id="{D79549AB-321A-450B-97D2-C5EAE5605957}"/>
               </a:ext>
             </a:extLst>
           </p:cNvPr>
@@ -14199,7 +14199,7 @@
           <p:cNvPr id="7" name="">
             <a:extLst xmlns:a="http://schemas.openxmlformats.org/drawingml/2006/main">
               <a:ext uri="{FF2B5EF4-FFF2-40B4-BE49-F238E27FC236}">
-                <a16:creationId xmlns:a16="http://schemas.microsoft.com/office/drawing/2014/main" id="{8B2B48C3-6E16-4965-88D7-767881B4281B}"/>
+                <a16:creationId xmlns:a16="http://schemas.microsoft.com/office/drawing/2014/main" id="{AD5A809F-4C61-4C0E-BE5D-83461871BAC1}"/>
               </a:ext>
             </a:extLst>
           </p:cNvPr>
@@ -14267,7 +14267,7 @@
           <p:cNvPr id="8" name="">
             <a:extLst xmlns:a="http://schemas.openxmlformats.org/drawingml/2006/main">
               <a:ext uri="{FF2B5EF4-FFF2-40B4-BE49-F238E27FC236}">
-                <a16:creationId xmlns:a16="http://schemas.microsoft.com/office/drawing/2014/main" id="{C0FE72EE-7185-40BF-954D-8E48BEF21A1D}"/>
+                <a16:creationId xmlns:a16="http://schemas.microsoft.com/office/drawing/2014/main" id="{450CDB37-D183-4774-A85C-442EBB8CB3E6}"/>
               </a:ext>
             </a:extLst>
           </p:cNvPr>
@@ -14335,7 +14335,7 @@
           <p:cNvPr id="9" name="">
             <a:extLst xmlns:a="http://schemas.openxmlformats.org/drawingml/2006/main">
               <a:ext uri="{FF2B5EF4-FFF2-40B4-BE49-F238E27FC236}">
-                <a16:creationId xmlns:a16="http://schemas.microsoft.com/office/drawing/2014/main" id="{D84D5AAC-33E2-4FAF-A81E-0B078C5503F4}"/>
+                <a16:creationId xmlns:a16="http://schemas.microsoft.com/office/drawing/2014/main" id="{10B0010A-8BDA-4B78-8A3A-44B23EE2CC16}"/>
               </a:ext>
             </a:extLst>
           </p:cNvPr>
@@ -14449,7 +14449,7 @@
           <p:cNvPr id="10" name="">
             <a:extLst xmlns:a="http://schemas.openxmlformats.org/drawingml/2006/main">
               <a:ext uri="{FF2B5EF4-FFF2-40B4-BE49-F238E27FC236}">
-                <a16:creationId xmlns:a16="http://schemas.microsoft.com/office/drawing/2014/main" id="{89D86D29-7802-41E0-9AE6-E9E1F97A5C86}"/>
+                <a16:creationId xmlns:a16="http://schemas.microsoft.com/office/drawing/2014/main" id="{C759DEA4-FEB2-473C-9371-D044A84AF031}"/>
               </a:ext>
             </a:extLst>
           </p:cNvPr>
@@ -14479,7 +14479,7 @@
           <p:cNvPr id="11" name="">
             <a:extLst xmlns:a="http://schemas.openxmlformats.org/drawingml/2006/main">
               <a:ext uri="{FF2B5EF4-FFF2-40B4-BE49-F238E27FC236}">
-                <a16:creationId xmlns:a16="http://schemas.microsoft.com/office/drawing/2014/main" id="{BA9FA3F0-B6F1-4200-9B22-0316E83441A7}"/>
+                <a16:creationId xmlns:a16="http://schemas.microsoft.com/office/drawing/2014/main" id="{9B6D5DB2-5D60-4314-8D40-27D99AD435EE}"/>
               </a:ext>
             </a:extLst>
           </p:cNvPr>
@@ -14547,7 +14547,7 @@
           <p:cNvPr id="12" name="">
             <a:extLst xmlns:a="http://schemas.openxmlformats.org/drawingml/2006/main">
               <a:ext uri="{FF2B5EF4-FFF2-40B4-BE49-F238E27FC236}">
-                <a16:creationId xmlns:a16="http://schemas.microsoft.com/office/drawing/2014/main" id="{FC4EC416-7B5C-48C7-80CF-850248E8DB17}"/>
+                <a16:creationId xmlns:a16="http://schemas.microsoft.com/office/drawing/2014/main" id="{CC520751-6A76-4D19-997D-3CAF8AE2DCBA}"/>
               </a:ext>
             </a:extLst>
           </p:cNvPr>
@@ -14615,7 +14615,7 @@
           <p:cNvPr id="13" name="">
             <a:extLst xmlns:a="http://schemas.openxmlformats.org/drawingml/2006/main">
               <a:ext uri="{FF2B5EF4-FFF2-40B4-BE49-F238E27FC236}">
-                <a16:creationId xmlns:a16="http://schemas.microsoft.com/office/drawing/2014/main" id="{1F593F27-1340-4AD0-B2F5-18634EF25EB3}"/>
+                <a16:creationId xmlns:a16="http://schemas.microsoft.com/office/drawing/2014/main" id="{A52EB73B-0EFE-40BD-AC07-CF6CEE4E365A}"/>
               </a:ext>
             </a:extLst>
           </p:cNvPr>
@@ -14729,7 +14729,7 @@
           <p:cNvPr id="14" name="">
             <a:extLst xmlns:a="http://schemas.openxmlformats.org/drawingml/2006/main">
               <a:ext uri="{FF2B5EF4-FFF2-40B4-BE49-F238E27FC236}">
-                <a16:creationId xmlns:a16="http://schemas.microsoft.com/office/drawing/2014/main" id="{EAE43908-C1E2-4D10-9C76-0771F16C20D7}"/>
+                <a16:creationId xmlns:a16="http://schemas.microsoft.com/office/drawing/2014/main" id="{7C13D92A-61FA-4E27-98AF-422374A48E38}"/>
               </a:ext>
             </a:extLst>
           </p:cNvPr>
@@ -14759,7 +14759,7 @@
           <p:cNvPr id="15" name="">
             <a:extLst xmlns:a="http://schemas.openxmlformats.org/drawingml/2006/main">
               <a:ext uri="{FF2B5EF4-FFF2-40B4-BE49-F238E27FC236}">
-                <a16:creationId xmlns:a16="http://schemas.microsoft.com/office/drawing/2014/main" id="{BA272FD8-21F3-4CF1-9F79-73D002741362}"/>
+                <a16:creationId xmlns:a16="http://schemas.microsoft.com/office/drawing/2014/main" id="{EC15834C-8507-4982-8551-02865AFC0118}"/>
               </a:ext>
             </a:extLst>
           </p:cNvPr>
@@ -14827,7 +14827,7 @@
           <p:cNvPr id="16" name="">
             <a:extLst xmlns:a="http://schemas.openxmlformats.org/drawingml/2006/main">
               <a:ext uri="{FF2B5EF4-FFF2-40B4-BE49-F238E27FC236}">
-                <a16:creationId xmlns:a16="http://schemas.microsoft.com/office/drawing/2014/main" id="{58BE9D5B-BA68-4B11-BC3F-33A6054E6835}"/>
+                <a16:creationId xmlns:a16="http://schemas.microsoft.com/office/drawing/2014/main" id="{626CBE44-F1BB-4A73-A06C-0426F44BA806}"/>
               </a:ext>
             </a:extLst>
           </p:cNvPr>
@@ -14895,7 +14895,7 @@
           <p:cNvPr id="17" name="">
             <a:extLst xmlns:a="http://schemas.openxmlformats.org/drawingml/2006/main">
               <a:ext uri="{FF2B5EF4-FFF2-40B4-BE49-F238E27FC236}">
-                <a16:creationId xmlns:a16="http://schemas.microsoft.com/office/drawing/2014/main" id="{F6215DFE-4A54-4EEB-9897-89ACE992AF15}"/>
+                <a16:creationId xmlns:a16="http://schemas.microsoft.com/office/drawing/2014/main" id="{3D9829FD-B553-4148-9EE8-C0368C139BC1}"/>
               </a:ext>
             </a:extLst>
           </p:cNvPr>
@@ -15009,7 +15009,7 @@
           <p:cNvPr id="18" name="">
             <a:extLst xmlns:a="http://schemas.openxmlformats.org/drawingml/2006/main">
               <a:ext uri="{FF2B5EF4-FFF2-40B4-BE49-F238E27FC236}">
-                <a16:creationId xmlns:a16="http://schemas.microsoft.com/office/drawing/2014/main" id="{1029DDEB-16B9-4186-ABC9-393C8E3287A8}"/>
+                <a16:creationId xmlns:a16="http://schemas.microsoft.com/office/drawing/2014/main" id="{130E9BF2-48F0-46C3-91A2-E754F3C95048}"/>
               </a:ext>
             </a:extLst>
           </p:cNvPr>
@@ -15039,7 +15039,7 @@
           <p:cNvPr id="19" name="">
             <a:extLst xmlns:a="http://schemas.openxmlformats.org/drawingml/2006/main">
               <a:ext uri="{FF2B5EF4-FFF2-40B4-BE49-F238E27FC236}">
-                <a16:creationId xmlns:a16="http://schemas.microsoft.com/office/drawing/2014/main" id="{DE70FC80-48A5-4000-AE54-D161374B9E11}"/>
+                <a16:creationId xmlns:a16="http://schemas.microsoft.com/office/drawing/2014/main" id="{58C58474-7B99-4B23-86D1-A35AAEE5C931}"/>
               </a:ext>
             </a:extLst>
           </p:cNvPr>
@@ -15107,7 +15107,7 @@
           <p:cNvPr id="20" name="">
             <a:extLst xmlns:a="http://schemas.openxmlformats.org/drawingml/2006/main">
               <a:ext uri="{FF2B5EF4-FFF2-40B4-BE49-F238E27FC236}">
-                <a16:creationId xmlns:a16="http://schemas.microsoft.com/office/drawing/2014/main" id="{151935FF-A2D8-4CCA-83D8-7DD4933703C5}"/>
+                <a16:creationId xmlns:a16="http://schemas.microsoft.com/office/drawing/2014/main" id="{BEDBF728-FC1F-42DF-9AF6-8E76BFD18E73}"/>
               </a:ext>
             </a:extLst>
           </p:cNvPr>
@@ -15175,7 +15175,7 @@
           <p:cNvPr id="21" name="">
             <a:extLst xmlns:a="http://schemas.openxmlformats.org/drawingml/2006/main">
               <a:ext uri="{FF2B5EF4-FFF2-40B4-BE49-F238E27FC236}">
-                <a16:creationId xmlns:a16="http://schemas.microsoft.com/office/drawing/2014/main" id="{97A9331A-0E63-4114-B4FA-80F782C3DF33}"/>
+                <a16:creationId xmlns:a16="http://schemas.microsoft.com/office/drawing/2014/main" id="{9C36B650-E494-4C16-A107-07985B7ED3FE}"/>
               </a:ext>
             </a:extLst>
           </p:cNvPr>
@@ -15289,7 +15289,7 @@
           <p:cNvPr id="22" name="">
             <a:extLst xmlns:a="http://schemas.openxmlformats.org/drawingml/2006/main">
               <a:ext uri="{FF2B5EF4-FFF2-40B4-BE49-F238E27FC236}">
-                <a16:creationId xmlns:a16="http://schemas.microsoft.com/office/drawing/2014/main" id="{A376C3E5-5D83-4D5E-A8C8-0F6BCA6D5E07}"/>
+                <a16:creationId xmlns:a16="http://schemas.microsoft.com/office/drawing/2014/main" id="{DCFC2E92-6807-4E4F-887A-1F8EAC6ED051}"/>
               </a:ext>
             </a:extLst>
           </p:cNvPr>
@@ -15319,7 +15319,7 @@
           <p:cNvPr id="23" name="">
             <a:extLst xmlns:a="http://schemas.openxmlformats.org/drawingml/2006/main">
               <a:ext uri="{FF2B5EF4-FFF2-40B4-BE49-F238E27FC236}">
-                <a16:creationId xmlns:a16="http://schemas.microsoft.com/office/drawing/2014/main" id="{3D056054-F8D5-4C27-81D5-AEF4C929332A}"/>
+                <a16:creationId xmlns:a16="http://schemas.microsoft.com/office/drawing/2014/main" id="{572B3AFF-9D6F-4500-86E2-97D9A63B6EA9}"/>
               </a:ext>
             </a:extLst>
           </p:cNvPr>
@@ -15387,7 +15387,7 @@
           <p:cNvPr id="24" name="">
             <a:extLst xmlns:a="http://schemas.openxmlformats.org/drawingml/2006/main">
               <a:ext uri="{FF2B5EF4-FFF2-40B4-BE49-F238E27FC236}">
-                <a16:creationId xmlns:a16="http://schemas.microsoft.com/office/drawing/2014/main" id="{B1A2C73E-B24A-4E46-A9FB-488B85BAB4A0}"/>
+                <a16:creationId xmlns:a16="http://schemas.microsoft.com/office/drawing/2014/main" id="{5F24C04E-2104-4A87-B05A-E37BE8315F84}"/>
               </a:ext>
             </a:extLst>
           </p:cNvPr>
@@ -15455,7 +15455,7 @@
           <p:cNvPr id="25" name="">
             <a:extLst xmlns:a="http://schemas.openxmlformats.org/drawingml/2006/main">
               <a:ext uri="{FF2B5EF4-FFF2-40B4-BE49-F238E27FC236}">
-                <a16:creationId xmlns:a16="http://schemas.microsoft.com/office/drawing/2014/main" id="{E2EB599E-EB5A-4C67-8736-3D30BBF467FB}"/>
+                <a16:creationId xmlns:a16="http://schemas.microsoft.com/office/drawing/2014/main" id="{B1BC0524-B6C4-4378-90A3-1B2F495F0B8F}"/>
               </a:ext>
             </a:extLst>
           </p:cNvPr>
@@ -15567,7 +15567,7 @@
     </p:spTree>
     <p:extLst>
       <p:ext uri="{BB962C8B-B14F-4D97-AF65-F5344CB8AC3E}">
-        <p14:creationId xmlns:p14="http://schemas.microsoft.com/office/powerpoint/2010/main" val="1862935412"/>
+        <p14:creationId xmlns:p14="http://schemas.microsoft.com/office/powerpoint/2010/main" val="1745115838"/>
       </p:ext>
     </p:extLst>
   </p:cSld>
@@ -15598,7 +15598,7 @@
           <p:cNvPr id="8" name="">
             <a:extLst xmlns:a="http://schemas.openxmlformats.org/drawingml/2006/main">
               <a:ext uri="{FF2B5EF4-FFF2-40B4-BE49-F238E27FC236}">
-                <a16:creationId xmlns:a16="http://schemas.microsoft.com/office/drawing/2014/main" id="{719121AE-99E2-46D2-BB17-28A1E6608DE9}"/>
+                <a16:creationId xmlns:a16="http://schemas.microsoft.com/office/drawing/2014/main" id="{BD530FD9-D972-440F-A5E4-183CD33C0A55}"/>
               </a:ext>
             </a:extLst>
           </p:cNvPr>
@@ -15666,7 +15666,7 @@
           <p:cNvPr id="2" name="">
             <a:extLst xmlns:a="http://schemas.openxmlformats.org/drawingml/2006/main">
               <a:ext uri="{FF2B5EF4-FFF2-40B4-BE49-F238E27FC236}">
-                <a16:creationId xmlns:a16="http://schemas.microsoft.com/office/drawing/2014/main" id="{5E764C4C-66A5-4D2E-85C6-0A206B11A4EF}"/>
+                <a16:creationId xmlns:a16="http://schemas.microsoft.com/office/drawing/2014/main" id="{601FEB98-7CCF-4833-8ACE-400E28EE8189}"/>
               </a:ext>
             </a:extLst>
           </p:cNvPr>
@@ -15734,7 +15734,7 @@
           <p:cNvPr id="3" name="">
             <a:extLst xmlns:a="http://schemas.openxmlformats.org/drawingml/2006/main">
               <a:ext uri="{FF2B5EF4-FFF2-40B4-BE49-F238E27FC236}">
-                <a16:creationId xmlns:a16="http://schemas.microsoft.com/office/drawing/2014/main" id="{4B39B13D-8A4A-4EC0-9C6C-A8BDE2DCBFB7}"/>
+                <a16:creationId xmlns:a16="http://schemas.microsoft.com/office/drawing/2014/main" id="{54ED0366-17E8-4E63-9C34-8C2393DE958D}"/>
               </a:ext>
             </a:extLst>
           </p:cNvPr>
@@ -15764,7 +15764,7 @@
           <p:cNvPr id="4" name="">
             <a:extLst xmlns:a="http://schemas.openxmlformats.org/drawingml/2006/main">
               <a:ext uri="{FF2B5EF4-FFF2-40B4-BE49-F238E27FC236}">
-                <a16:creationId xmlns:a16="http://schemas.microsoft.com/office/drawing/2014/main" id="{32526861-58E1-4615-AAB5-CE778268D7ED}"/>
+                <a16:creationId xmlns:a16="http://schemas.microsoft.com/office/drawing/2014/main" id="{3B418C7E-25E8-4A5A-8BA5-101304EE717B}"/>
               </a:ext>
             </a:extLst>
           </p:cNvPr>
@@ -15832,7 +15832,7 @@
           <p:cNvPr id="5" name="">
             <a:extLst xmlns:a="http://schemas.openxmlformats.org/drawingml/2006/main">
               <a:ext uri="{FF2B5EF4-FFF2-40B4-BE49-F238E27FC236}">
-                <a16:creationId xmlns:a16="http://schemas.microsoft.com/office/drawing/2014/main" id="{252B4A72-0813-43A6-9386-5364B212FAC1}"/>
+                <a16:creationId xmlns:a16="http://schemas.microsoft.com/office/drawing/2014/main" id="{B1312081-ACBD-4927-A3E1-847CBEAA0F31}"/>
               </a:ext>
             </a:extLst>
           </p:cNvPr>
@@ -15900,7 +15900,7 @@
           <p:cNvPr id="6" name="Chart">
             <a:extLst xmlns:a="http://schemas.openxmlformats.org/drawingml/2006/main">
               <a:ext uri="{FF2B5EF4-FFF2-40B4-BE49-F238E27FC236}">
-                <a16:creationId xmlns:a16="http://schemas.microsoft.com/office/drawing/2014/main" id="{FED6CAEB-1331-448D-A229-69740FAC9BC4}"/>
+                <a16:creationId xmlns:a16="http://schemas.microsoft.com/office/drawing/2014/main" id="{46870A65-4FBC-441E-BFBF-BFDF7DDF125E}"/>
               </a:ext>
             </a:extLst>
           </p:cNvPr>
@@ -15913,7 +15913,7 @@
         </p:xfrm>
         <a:graphic xmlns:a="http://schemas.openxmlformats.org/drawingml/2006/main">
           <a:graphicData uri="http://schemas.openxmlformats.org/drawingml/2006/chart">
-            <c:chart xmlns:r="http://schemas.openxmlformats.org/officeDocument/2006/relationships" xmlns:c="http://schemas.openxmlformats.org/drawingml/2006/chart" r:id="R1533ed14d920428d"/>
+            <c:chart xmlns:r="http://schemas.openxmlformats.org/officeDocument/2006/relationships" xmlns:c="http://schemas.openxmlformats.org/drawingml/2006/chart" r:id="R8521f0be93444c8e"/>
           </a:graphicData>
         </a:graphic>
       </p:graphicFrame>
@@ -15922,7 +15922,7 @@
           <p:cNvPr id="7" name="">
             <a:extLst xmlns:a="http://schemas.openxmlformats.org/drawingml/2006/main">
               <a:ext uri="{FF2B5EF4-FFF2-40B4-BE49-F238E27FC236}">
-                <a16:creationId xmlns:a16="http://schemas.microsoft.com/office/drawing/2014/main" id="{B69D63B0-D9A9-4D5E-AF93-FDDAC29DC655}"/>
+                <a16:creationId xmlns:a16="http://schemas.microsoft.com/office/drawing/2014/main" id="{6E391C9D-C9B1-4478-9735-144331648372}"/>
               </a:ext>
             </a:extLst>
           </p:cNvPr>
@@ -15988,7 +15988,7 @@
     </p:spTree>
     <p:extLst>
       <p:ext uri="{BB962C8B-B14F-4D97-AF65-F5344CB8AC3E}">
-        <p14:creationId xmlns:p14="http://schemas.microsoft.com/office/powerpoint/2010/main" val="1340929674"/>
+        <p14:creationId xmlns:p14="http://schemas.microsoft.com/office/powerpoint/2010/main" val="1399490933"/>
       </p:ext>
     </p:extLst>
   </p:cSld>
@@ -16019,7 +16019,7 @@
           <p:cNvPr id="8" name="">
             <a:extLst xmlns:a="http://schemas.openxmlformats.org/drawingml/2006/main">
               <a:ext uri="{FF2B5EF4-FFF2-40B4-BE49-F238E27FC236}">
-                <a16:creationId xmlns:a16="http://schemas.microsoft.com/office/drawing/2014/main" id="{BC223950-CEA6-48D7-AFA3-A8A61FCEEC4E}"/>
+                <a16:creationId xmlns:a16="http://schemas.microsoft.com/office/drawing/2014/main" id="{FA60E2C2-2DCC-477F-A1A6-E19DA7F0E66E}"/>
               </a:ext>
             </a:extLst>
           </p:cNvPr>
@@ -16087,7 +16087,7 @@
           <p:cNvPr id="2" name="">
             <a:extLst xmlns:a="http://schemas.openxmlformats.org/drawingml/2006/main">
               <a:ext uri="{FF2B5EF4-FFF2-40B4-BE49-F238E27FC236}">
-                <a16:creationId xmlns:a16="http://schemas.microsoft.com/office/drawing/2014/main" id="{2AFBBB4E-EE51-4F19-A981-65A14267E811}"/>
+                <a16:creationId xmlns:a16="http://schemas.microsoft.com/office/drawing/2014/main" id="{14008305-474B-4089-AC7C-49856A74EE50}"/>
               </a:ext>
             </a:extLst>
           </p:cNvPr>
@@ -16155,7 +16155,7 @@
           <p:cNvPr id="3" name="">
             <a:extLst xmlns:a="http://schemas.openxmlformats.org/drawingml/2006/main">
               <a:ext uri="{FF2B5EF4-FFF2-40B4-BE49-F238E27FC236}">
-                <a16:creationId xmlns:a16="http://schemas.microsoft.com/office/drawing/2014/main" id="{437419AC-F4CC-44B8-A4F2-4076BE40C080}"/>
+                <a16:creationId xmlns:a16="http://schemas.microsoft.com/office/drawing/2014/main" id="{3DEDDC0A-9395-4674-BC0A-7F8E3C3D3A85}"/>
               </a:ext>
             </a:extLst>
           </p:cNvPr>
@@ -16185,7 +16185,7 @@
           <p:cNvPr id="4" name="">
             <a:extLst xmlns:a="http://schemas.openxmlformats.org/drawingml/2006/main">
               <a:ext uri="{FF2B5EF4-FFF2-40B4-BE49-F238E27FC236}">
-                <a16:creationId xmlns:a16="http://schemas.microsoft.com/office/drawing/2014/main" id="{779AA9E5-8E2C-4629-88C3-07029090C7E8}"/>
+                <a16:creationId xmlns:a16="http://schemas.microsoft.com/office/drawing/2014/main" id="{61729BCE-8507-48C2-82ED-9A4F56D4B41D}"/>
               </a:ext>
             </a:extLst>
           </p:cNvPr>
@@ -16253,7 +16253,7 @@
           <p:cNvPr id="5" name="">
             <a:extLst xmlns:a="http://schemas.openxmlformats.org/drawingml/2006/main">
               <a:ext uri="{FF2B5EF4-FFF2-40B4-BE49-F238E27FC236}">
-                <a16:creationId xmlns:a16="http://schemas.microsoft.com/office/drawing/2014/main" id="{6F5684D1-2626-4D81-9C31-4BF1FF1F9601}"/>
+                <a16:creationId xmlns:a16="http://schemas.microsoft.com/office/drawing/2014/main" id="{87D38A1B-73CE-4E42-92B0-8783A0730FD8}"/>
               </a:ext>
             </a:extLst>
           </p:cNvPr>
@@ -16321,7 +16321,7 @@
           <p:cNvPr id="6" name="">
             <a:extLst xmlns:a="http://schemas.openxmlformats.org/drawingml/2006/main">
               <a:ext uri="{FF2B5EF4-FFF2-40B4-BE49-F238E27FC236}">
-                <a16:creationId xmlns:a16="http://schemas.microsoft.com/office/drawing/2014/main" id="{9FCF740E-A5B5-40DB-BBC8-DE90E562972F}"/>
+                <a16:creationId xmlns:a16="http://schemas.microsoft.com/office/drawing/2014/main" id="{5E92F984-DB44-460F-BD0C-104DAFF6907F}"/>
               </a:ext>
             </a:extLst>
           </p:cNvPr>
@@ -16794,7 +16794,7 @@
           <p:cNvPr id="7" name="">
             <a:extLst xmlns:a="http://schemas.openxmlformats.org/drawingml/2006/main">
               <a:ext uri="{FF2B5EF4-FFF2-40B4-BE49-F238E27FC236}">
-                <a16:creationId xmlns:a16="http://schemas.microsoft.com/office/drawing/2014/main" id="{D360E123-269B-453F-B800-FF247B9F5852}"/>
+                <a16:creationId xmlns:a16="http://schemas.microsoft.com/office/drawing/2014/main" id="{DA84ADAA-3250-42C8-B4B2-A04E30EC6B50}"/>
               </a:ext>
             </a:extLst>
           </p:cNvPr>
@@ -16860,7 +16860,7 @@
     </p:spTree>
     <p:extLst>
       <p:ext uri="{BB962C8B-B14F-4D97-AF65-F5344CB8AC3E}">
-        <p14:creationId xmlns:p14="http://schemas.microsoft.com/office/powerpoint/2010/main" val="1838535834"/>
+        <p14:creationId xmlns:p14="http://schemas.microsoft.com/office/powerpoint/2010/main" val="285980244"/>
       </p:ext>
     </p:extLst>
   </p:cSld>
@@ -16891,7 +16891,7 @@
           <p:cNvPr id="11" name="">
             <a:extLst xmlns:a="http://schemas.openxmlformats.org/drawingml/2006/main">
               <a:ext uri="{FF2B5EF4-FFF2-40B4-BE49-F238E27FC236}">
-                <a16:creationId xmlns:a16="http://schemas.microsoft.com/office/drawing/2014/main" id="{6C62C3BA-7BFF-4354-91DD-BBB016CBACDC}"/>
+                <a16:creationId xmlns:a16="http://schemas.microsoft.com/office/drawing/2014/main" id="{01C4E0AA-F0C6-45B8-9F46-29781D4B71C9}"/>
               </a:ext>
             </a:extLst>
           </p:cNvPr>
@@ -16959,7 +16959,7 @@
           <p:cNvPr id="2" name="">
             <a:extLst xmlns:a="http://schemas.openxmlformats.org/drawingml/2006/main">
               <a:ext uri="{FF2B5EF4-FFF2-40B4-BE49-F238E27FC236}">
-                <a16:creationId xmlns:a16="http://schemas.microsoft.com/office/drawing/2014/main" id="{B2925425-E63C-47EC-BDB7-98ECFAA61DBB}"/>
+                <a16:creationId xmlns:a16="http://schemas.microsoft.com/office/drawing/2014/main" id="{CEFD5813-F5E9-4C0F-9113-455DAFCF0434}"/>
               </a:ext>
             </a:extLst>
           </p:cNvPr>
@@ -17027,7 +17027,7 @@
           <p:cNvPr id="3" name="">
             <a:extLst xmlns:a="http://schemas.openxmlformats.org/drawingml/2006/main">
               <a:ext uri="{FF2B5EF4-FFF2-40B4-BE49-F238E27FC236}">
-                <a16:creationId xmlns:a16="http://schemas.microsoft.com/office/drawing/2014/main" id="{A35844E1-7E06-487E-B155-70C7217CEAD7}"/>
+                <a16:creationId xmlns:a16="http://schemas.microsoft.com/office/drawing/2014/main" id="{F96D9673-C19C-4765-9864-7D2E786BD95B}"/>
               </a:ext>
             </a:extLst>
           </p:cNvPr>
@@ -17057,7 +17057,7 @@
           <p:cNvPr id="4" name="">
             <a:extLst xmlns:a="http://schemas.openxmlformats.org/drawingml/2006/main">
               <a:ext uri="{FF2B5EF4-FFF2-40B4-BE49-F238E27FC236}">
-                <a16:creationId xmlns:a16="http://schemas.microsoft.com/office/drawing/2014/main" id="{1ECFCABD-7657-4342-968A-2D3B7555DB59}"/>
+                <a16:creationId xmlns:a16="http://schemas.microsoft.com/office/drawing/2014/main" id="{E29BC5A7-B1A8-4CCE-AD2A-D2422BFA52A4}"/>
               </a:ext>
             </a:extLst>
           </p:cNvPr>
@@ -17125,7 +17125,7 @@
           <p:cNvPr id="5" name="">
             <a:extLst xmlns:a="http://schemas.openxmlformats.org/drawingml/2006/main">
               <a:ext uri="{FF2B5EF4-FFF2-40B4-BE49-F238E27FC236}">
-                <a16:creationId xmlns:a16="http://schemas.microsoft.com/office/drawing/2014/main" id="{CC4F7505-B851-41D0-B390-1AD99D7C86E1}"/>
+                <a16:creationId xmlns:a16="http://schemas.microsoft.com/office/drawing/2014/main" id="{434C4136-0E33-44F3-8710-DE6A74EA85D4}"/>
               </a:ext>
             </a:extLst>
           </p:cNvPr>
@@ -17193,7 +17193,7 @@
           <p:cNvPr id="6" name="">
             <a:extLst xmlns:a="http://schemas.openxmlformats.org/drawingml/2006/main">
               <a:ext uri="{FF2B5EF4-FFF2-40B4-BE49-F238E27FC236}">
-                <a16:creationId xmlns:a16="http://schemas.microsoft.com/office/drawing/2014/main" id="{09F2FAC6-63FB-4C95-9BF0-656A6709F4F0}"/>
+                <a16:creationId xmlns:a16="http://schemas.microsoft.com/office/drawing/2014/main" id="{EA496D82-F1CF-45CF-8AB8-B16C7387EA7B}"/>
               </a:ext>
             </a:extLst>
           </p:cNvPr>
@@ -17261,7 +17261,7 @@
           <p:cNvPr id="7" name="">
             <a:extLst xmlns:a="http://schemas.openxmlformats.org/drawingml/2006/main">
               <a:ext uri="{FF2B5EF4-FFF2-40B4-BE49-F238E27FC236}">
-                <a16:creationId xmlns:a16="http://schemas.microsoft.com/office/drawing/2014/main" id="{9F6F7A75-2D3E-422D-9327-564492409A96}"/>
+                <a16:creationId xmlns:a16="http://schemas.microsoft.com/office/drawing/2014/main" id="{19560590-1AAF-4A77-B25B-A462D1B36EFB}"/>
               </a:ext>
             </a:extLst>
           </p:cNvPr>
@@ -17398,7 +17398,7 @@
           <p:cNvPr id="8" name="">
             <a:extLst xmlns:a="http://schemas.openxmlformats.org/drawingml/2006/main">
               <a:ext uri="{FF2B5EF4-FFF2-40B4-BE49-F238E27FC236}">
-                <a16:creationId xmlns:a16="http://schemas.microsoft.com/office/drawing/2014/main" id="{C6F9B203-A392-4337-9458-7FCF99CE9869}"/>
+                <a16:creationId xmlns:a16="http://schemas.microsoft.com/office/drawing/2014/main" id="{406A2656-A52B-453B-8466-74514C133584}"/>
               </a:ext>
             </a:extLst>
           </p:cNvPr>
@@ -17466,7 +17466,7 @@
           <p:cNvPr id="9" name="">
             <a:extLst xmlns:a="http://schemas.openxmlformats.org/drawingml/2006/main">
               <a:ext uri="{FF2B5EF4-FFF2-40B4-BE49-F238E27FC236}">
-                <a16:creationId xmlns:a16="http://schemas.microsoft.com/office/drawing/2014/main" id="{5FC4BEBE-B261-476A-8D16-815C803894E4}"/>
+                <a16:creationId xmlns:a16="http://schemas.microsoft.com/office/drawing/2014/main" id="{4D1B72B5-BFF6-4683-91D1-91DAFC4D339F}"/>
               </a:ext>
             </a:extLst>
           </p:cNvPr>
@@ -17603,7 +17603,7 @@
           <p:cNvPr id="10" name="">
             <a:extLst xmlns:a="http://schemas.openxmlformats.org/drawingml/2006/main">
               <a:ext uri="{FF2B5EF4-FFF2-40B4-BE49-F238E27FC236}">
-                <a16:creationId xmlns:a16="http://schemas.microsoft.com/office/drawing/2014/main" id="{478D1628-D84F-4EF2-A8D2-51576CCF6FBA}"/>
+                <a16:creationId xmlns:a16="http://schemas.microsoft.com/office/drawing/2014/main" id="{839D9A2A-BF0B-4ED4-93CD-56A6076D4B8E}"/>
               </a:ext>
             </a:extLst>
           </p:cNvPr>
@@ -17669,7 +17669,7 @@
     </p:spTree>
     <p:extLst>
       <p:ext uri="{BB962C8B-B14F-4D97-AF65-F5344CB8AC3E}">
-        <p14:creationId xmlns:p14="http://schemas.microsoft.com/office/powerpoint/2010/main" val="2108431550"/>
+        <p14:creationId xmlns:p14="http://schemas.microsoft.com/office/powerpoint/2010/main" val="576580032"/>
       </p:ext>
     </p:extLst>
   </p:cSld>
@@ -17700,7 +17700,7 @@
           <p:cNvPr id="8" name="">
             <a:extLst xmlns:a="http://schemas.openxmlformats.org/drawingml/2006/main">
               <a:ext uri="{FF2B5EF4-FFF2-40B4-BE49-F238E27FC236}">
-                <a16:creationId xmlns:a16="http://schemas.microsoft.com/office/drawing/2014/main" id="{E3BA98BA-F948-44DC-8749-B85E94C3DFFB}"/>
+                <a16:creationId xmlns:a16="http://schemas.microsoft.com/office/drawing/2014/main" id="{8C63A382-B725-4FA0-8760-8F7129BC691E}"/>
               </a:ext>
             </a:extLst>
           </p:cNvPr>
@@ -17768,7 +17768,7 @@
           <p:cNvPr id="2" name="">
             <a:extLst xmlns:a="http://schemas.openxmlformats.org/drawingml/2006/main">
               <a:ext uri="{FF2B5EF4-FFF2-40B4-BE49-F238E27FC236}">
-                <a16:creationId xmlns:a16="http://schemas.microsoft.com/office/drawing/2014/main" id="{BED3CAB1-62B0-46C6-83EA-73B480E2BDD6}"/>
+                <a16:creationId xmlns:a16="http://schemas.microsoft.com/office/drawing/2014/main" id="{9CB4AE52-2248-490A-B95E-46773A2F248A}"/>
               </a:ext>
             </a:extLst>
           </p:cNvPr>
@@ -17836,7 +17836,7 @@
           <p:cNvPr id="3" name="">
             <a:extLst xmlns:a="http://schemas.openxmlformats.org/drawingml/2006/main">
               <a:ext uri="{FF2B5EF4-FFF2-40B4-BE49-F238E27FC236}">
-                <a16:creationId xmlns:a16="http://schemas.microsoft.com/office/drawing/2014/main" id="{32275627-CADF-45B4-AA77-146257CFB4C9}"/>
+                <a16:creationId xmlns:a16="http://schemas.microsoft.com/office/drawing/2014/main" id="{B582075D-70E6-4621-B751-5C08DEDE0056}"/>
               </a:ext>
             </a:extLst>
           </p:cNvPr>
@@ -17866,7 +17866,7 @@
           <p:cNvPr id="4" name="">
             <a:extLst xmlns:a="http://schemas.openxmlformats.org/drawingml/2006/main">
               <a:ext uri="{FF2B5EF4-FFF2-40B4-BE49-F238E27FC236}">
-                <a16:creationId xmlns:a16="http://schemas.microsoft.com/office/drawing/2014/main" id="{4839AD93-0121-465F-ACF6-6AE6F394EEAE}"/>
+                <a16:creationId xmlns:a16="http://schemas.microsoft.com/office/drawing/2014/main" id="{F7AA7C01-4957-4E7D-83C8-E0F48F7CA308}"/>
               </a:ext>
             </a:extLst>
           </p:cNvPr>
@@ -17934,7 +17934,7 @@
           <p:cNvPr id="5" name="">
             <a:extLst xmlns:a="http://schemas.openxmlformats.org/drawingml/2006/main">
               <a:ext uri="{FF2B5EF4-FFF2-40B4-BE49-F238E27FC236}">
-                <a16:creationId xmlns:a16="http://schemas.microsoft.com/office/drawing/2014/main" id="{260533A7-7E8A-4E73-B9DF-9D0854AA0C91}"/>
+                <a16:creationId xmlns:a16="http://schemas.microsoft.com/office/drawing/2014/main" id="{1C3E24C8-2C7F-4712-9EA1-D2E4C8446CF9}"/>
               </a:ext>
             </a:extLst>
           </p:cNvPr>
@@ -18002,7 +18002,7 @@
           <p:cNvPr id="6" name="Chart">
             <a:extLst xmlns:a="http://schemas.openxmlformats.org/drawingml/2006/main">
               <a:ext uri="{FF2B5EF4-FFF2-40B4-BE49-F238E27FC236}">
-                <a16:creationId xmlns:a16="http://schemas.microsoft.com/office/drawing/2014/main" id="{BFCA3037-241D-418A-9543-17409DBDE674}"/>
+                <a16:creationId xmlns:a16="http://schemas.microsoft.com/office/drawing/2014/main" id="{801ABED7-AF39-42C9-885D-FD3D55E193FA}"/>
               </a:ext>
             </a:extLst>
           </p:cNvPr>
@@ -18015,7 +18015,7 @@
         </p:xfrm>
         <a:graphic xmlns:a="http://schemas.openxmlformats.org/drawingml/2006/main">
           <a:graphicData uri="http://schemas.openxmlformats.org/drawingml/2006/chart">
-            <c:chart xmlns:r="http://schemas.openxmlformats.org/officeDocument/2006/relationships" xmlns:c="http://schemas.openxmlformats.org/drawingml/2006/chart" r:id="R0dff9bde13ec4a30"/>
+            <c:chart xmlns:r="http://schemas.openxmlformats.org/officeDocument/2006/relationships" xmlns:c="http://schemas.openxmlformats.org/drawingml/2006/chart" r:id="R7ed3de0b1bbb498d"/>
           </a:graphicData>
         </a:graphic>
       </p:graphicFrame>
@@ -18024,7 +18024,7 @@
           <p:cNvPr id="7" name="">
             <a:extLst xmlns:a="http://schemas.openxmlformats.org/drawingml/2006/main">
               <a:ext uri="{FF2B5EF4-FFF2-40B4-BE49-F238E27FC236}">
-                <a16:creationId xmlns:a16="http://schemas.microsoft.com/office/drawing/2014/main" id="{C84F27B1-9822-4F56-A670-211CE69CF561}"/>
+                <a16:creationId xmlns:a16="http://schemas.microsoft.com/office/drawing/2014/main" id="{FBBEB267-CB07-4171-ADF0-72CAB9CB70F5}"/>
               </a:ext>
             </a:extLst>
           </p:cNvPr>
@@ -18090,7 +18090,7 @@
     </p:spTree>
     <p:extLst>
       <p:ext uri="{BB962C8B-B14F-4D97-AF65-F5344CB8AC3E}">
-        <p14:creationId xmlns:p14="http://schemas.microsoft.com/office/powerpoint/2010/main" val="1459041420"/>
+        <p14:creationId xmlns:p14="http://schemas.microsoft.com/office/powerpoint/2010/main" val="538048806"/>
       </p:ext>
     </p:extLst>
   </p:cSld>

</xml_diff>